<commit_message>
Final submission deliverables: updated README, live Render deployment, final presentation deck, demo video, and cleaned codebase
</commit_message>
<xml_diff>
--- a/ppt/retinascan-ai-v1.pptx
+++ b/ppt/retinascan-ai-v1.pptx
@@ -161,6 +161,134 @@
 </p:presentation>
 </file>
 
+<file path=ppt/changesInfos/changesInfo1.xml><?xml version="1.0" encoding="utf-8"?>
+<pc:chgInfo xmlns:a="http://schemas.openxmlformats.org/drawingml/2006/main" xmlns:r="http://schemas.openxmlformats.org/officeDocument/2006/relationships" xmlns:ac="http://schemas.microsoft.com/office/drawing/2013/main/command" xmlns:pc="http://schemas.microsoft.com/office/powerpoint/2013/main/command">
+  <pc:docChgLst>
+    <pc:chgData name="Tushar Koli" userId="008641bab1ba28e0" providerId="LiveId" clId="{AF9D182C-6BA4-45C4-8211-09F81F872F4F}"/>
+    <pc:docChg chg="custSel modSld">
+      <pc:chgData name="Tushar Koli" userId="008641bab1ba28e0" providerId="LiveId" clId="{AF9D182C-6BA4-45C4-8211-09F81F872F4F}" dt="2026-09-09T11:18:36.177" v="35" actId="1076"/>
+      <pc:docMkLst>
+        <pc:docMk/>
+      </pc:docMkLst>
+      <pc:sldChg chg="addSp delSp modSp mod">
+        <pc:chgData name="Tushar Koli" userId="008641bab1ba28e0" providerId="LiveId" clId="{AF9D182C-6BA4-45C4-8211-09F81F872F4F}" dt="2026-08-30T11:46:52.036" v="24" actId="1076"/>
+        <pc:sldMkLst>
+          <pc:docMk/>
+          <pc:sldMk cId="3807895206" sldId="298"/>
+        </pc:sldMkLst>
+        <pc:spChg chg="mod">
+          <ac:chgData name="Tushar Koli" userId="008641bab1ba28e0" providerId="LiveId" clId="{AF9D182C-6BA4-45C4-8211-09F81F872F4F}" dt="2026-08-30T11:46:52.036" v="24" actId="1076"/>
+          <ac:spMkLst>
+            <pc:docMk/>
+            <pc:sldMk cId="3807895206" sldId="298"/>
+            <ac:spMk id="21" creationId="{DE2DE442-FC1D-AA22-5EFC-A93D236F1CCE}"/>
+          </ac:spMkLst>
+        </pc:spChg>
+        <pc:picChg chg="add mod">
+          <ac:chgData name="Tushar Koli" userId="008641bab1ba28e0" providerId="LiveId" clId="{AF9D182C-6BA4-45C4-8211-09F81F872F4F}" dt="2026-08-30T11:46:48.419" v="23" actId="1076"/>
+          <ac:picMkLst>
+            <pc:docMk/>
+            <pc:sldMk cId="3807895206" sldId="298"/>
+            <ac:picMk id="4" creationId="{A70D289A-766A-620B-85FD-871B699E31FA}"/>
+          </ac:picMkLst>
+        </pc:picChg>
+      </pc:sldChg>
+      <pc:sldChg chg="addSp delSp mod">
+        <pc:chgData name="Tushar Koli" userId="008641bab1ba28e0" providerId="LiveId" clId="{AF9D182C-6BA4-45C4-8211-09F81F872F4F}" dt="2026-08-30T11:46:39.535" v="20" actId="22"/>
+        <pc:sldMkLst>
+          <pc:docMk/>
+          <pc:sldMk cId="3798438792" sldId="299"/>
+        </pc:sldMkLst>
+        <pc:picChg chg="add">
+          <ac:chgData name="Tushar Koli" userId="008641bab1ba28e0" providerId="LiveId" clId="{AF9D182C-6BA4-45C4-8211-09F81F872F4F}" dt="2026-08-30T11:46:39.535" v="20" actId="22"/>
+          <ac:picMkLst>
+            <pc:docMk/>
+            <pc:sldMk cId="3798438792" sldId="299"/>
+            <ac:picMk id="3" creationId="{81E66511-69DB-7291-3CDC-C34164EFC093}"/>
+          </ac:picMkLst>
+        </pc:picChg>
+      </pc:sldChg>
+      <pc:sldChg chg="addSp delSp modSp mod">
+        <pc:chgData name="Tushar Koli" userId="008641bab1ba28e0" providerId="LiveId" clId="{AF9D182C-6BA4-45C4-8211-09F81F872F4F}" dt="2026-09-09T11:18:36.177" v="35" actId="1076"/>
+        <pc:sldMkLst>
+          <pc:docMk/>
+          <pc:sldMk cId="2401937804" sldId="300"/>
+        </pc:sldMkLst>
+        <pc:spChg chg="mod">
+          <ac:chgData name="Tushar Koli" userId="008641bab1ba28e0" providerId="LiveId" clId="{AF9D182C-6BA4-45C4-8211-09F81F872F4F}" dt="2026-08-30T11:56:46.679" v="34" actId="1076"/>
+          <ac:spMkLst>
+            <pc:docMk/>
+            <pc:sldMk cId="2401937804" sldId="300"/>
+            <ac:spMk id="16" creationId="{78943C23-1BD2-3379-5A8C-7334E1BB3DF8}"/>
+          </ac:spMkLst>
+        </pc:spChg>
+        <pc:spChg chg="mod">
+          <ac:chgData name="Tushar Koli" userId="008641bab1ba28e0" providerId="LiveId" clId="{AF9D182C-6BA4-45C4-8211-09F81F872F4F}" dt="2026-09-09T11:18:36.177" v="35" actId="1076"/>
+          <ac:spMkLst>
+            <pc:docMk/>
+            <pc:sldMk cId="2401937804" sldId="300"/>
+            <ac:spMk id="19" creationId="{00E1D1FF-0706-497D-BB82-D470B4C5049C}"/>
+          </ac:spMkLst>
+        </pc:spChg>
+        <pc:picChg chg="add mod">
+          <ac:chgData name="Tushar Koli" userId="008641bab1ba28e0" providerId="LiveId" clId="{AF9D182C-6BA4-45C4-8211-09F81F872F4F}" dt="2026-08-30T11:46:05.087" v="7" actId="1076"/>
+          <ac:picMkLst>
+            <pc:docMk/>
+            <pc:sldMk cId="2401937804" sldId="300"/>
+            <ac:picMk id="9" creationId="{6D0D0099-7BE6-5418-9B08-2D2D84B17565}"/>
+          </ac:picMkLst>
+        </pc:picChg>
+      </pc:sldChg>
+      <pc:sldChg chg="addSp delSp modSp mod">
+        <pc:chgData name="Tushar Koli" userId="008641bab1ba28e0" providerId="LiveId" clId="{AF9D182C-6BA4-45C4-8211-09F81F872F4F}" dt="2026-08-30T11:46:21.478" v="13" actId="1076"/>
+        <pc:sldMkLst>
+          <pc:docMk/>
+          <pc:sldMk cId="3156105987" sldId="301"/>
+        </pc:sldMkLst>
+        <pc:picChg chg="add mod">
+          <ac:chgData name="Tushar Koli" userId="008641bab1ba28e0" providerId="LiveId" clId="{AF9D182C-6BA4-45C4-8211-09F81F872F4F}" dt="2026-08-30T11:46:21.478" v="13" actId="1076"/>
+          <ac:picMkLst>
+            <pc:docMk/>
+            <pc:sldMk cId="3156105987" sldId="301"/>
+            <ac:picMk id="3" creationId="{D1F9ABAF-5DB4-C921-4F6D-7D4EF8F97070}"/>
+          </ac:picMkLst>
+        </pc:picChg>
+      </pc:sldChg>
+      <pc:sldChg chg="addSp delSp modSp mod">
+        <pc:chgData name="Tushar Koli" userId="008641bab1ba28e0" providerId="LiveId" clId="{AF9D182C-6BA4-45C4-8211-09F81F872F4F}" dt="2026-08-30T11:46:27.489" v="16" actId="1076"/>
+        <pc:sldMkLst>
+          <pc:docMk/>
+          <pc:sldMk cId="1720093738" sldId="302"/>
+        </pc:sldMkLst>
+        <pc:picChg chg="add mod">
+          <ac:chgData name="Tushar Koli" userId="008641bab1ba28e0" providerId="LiveId" clId="{AF9D182C-6BA4-45C4-8211-09F81F872F4F}" dt="2026-08-30T11:46:27.489" v="16" actId="1076"/>
+          <ac:picMkLst>
+            <pc:docMk/>
+            <pc:sldMk cId="1720093738" sldId="302"/>
+            <ac:picMk id="5" creationId="{62E03E21-C792-1363-2E79-10233DBDB4A0}"/>
+          </ac:picMkLst>
+        </pc:picChg>
+      </pc:sldChg>
+      <pc:sldChg chg="addSp delSp mod">
+        <pc:chgData name="Tushar Koli" userId="008641bab1ba28e0" providerId="LiveId" clId="{AF9D182C-6BA4-45C4-8211-09F81F872F4F}" dt="2026-08-30T11:46:31.406" v="18" actId="22"/>
+        <pc:sldMkLst>
+          <pc:docMk/>
+          <pc:sldMk cId="443272367" sldId="303"/>
+        </pc:sldMkLst>
+        <pc:picChg chg="add">
+          <ac:chgData name="Tushar Koli" userId="008641bab1ba28e0" providerId="LiveId" clId="{AF9D182C-6BA4-45C4-8211-09F81F872F4F}" dt="2026-08-30T11:46:31.406" v="18" actId="22"/>
+          <ac:picMkLst>
+            <pc:docMk/>
+            <pc:sldMk cId="443272367" sldId="303"/>
+            <ac:picMk id="3" creationId="{EA5A9DB6-6FEE-0539-AB6D-0E5F53D4FD06}"/>
+          </ac:picMkLst>
+        </pc:picChg>
+      </pc:sldChg>
+    </pc:docChg>
+  </pc:docChgLst>
+</pc:chgInfo>
+</file>
+
 <file path=ppt/notesMasters/notesMaster1.xml><?xml version="1.0" encoding="utf-8"?>
 <p:notesMaster xmlns:a="http://schemas.openxmlformats.org/drawingml/2006/main" xmlns:r="http://schemas.openxmlformats.org/officeDocument/2006/relationships" xmlns:p="http://schemas.openxmlformats.org/presentationml/2006/main">
   <p:cSld>
@@ -261,7 +389,7 @@
             <a:fld id="{C4D5ADD5-2BBC-4A94-8F86-D9013941F742}" type="datetimeFigureOut">
               <a:rPr lang="en-US"/>
               <a:pPr/>
-              <a:t>8/27/2026</a:t>
+              <a:t>9/9/2026</a:t>
             </a:fld>
             <a:endParaRPr lang="en-US"/>
           </a:p>
@@ -1416,7 +1544,7 @@
           <a:p>
             <a:fld id="{E60792E3-D524-454C-8AFD-A91972900BCB}" type="datetime1">
               <a:rPr lang="en-US" smtClean="0"/>
-              <a:t>8/27/2026</a:t>
+              <a:t>9/9/2026</a:t>
             </a:fld>
             <a:endParaRPr lang="en-US"/>
           </a:p>
@@ -1598,7 +1726,7 @@
           <a:p>
             <a:fld id="{053C3A68-6922-42D3-8905-ECC2D82A3469}" type="datetime1">
               <a:rPr lang="en-US" smtClean="0"/>
-              <a:t>8/27/2026</a:t>
+              <a:t>9/9/2026</a:t>
             </a:fld>
             <a:endParaRPr lang="en-US"/>
           </a:p>
@@ -1790,7 +1918,7 @@
           <a:p>
             <a:fld id="{CB69E9F4-7604-4950-A8B2-8ACDEDB1506E}" type="datetime1">
               <a:rPr lang="en-US" smtClean="0"/>
-              <a:t>8/27/2026</a:t>
+              <a:t>9/9/2026</a:t>
             </a:fld>
             <a:endParaRPr lang="en-US"/>
           </a:p>
@@ -1972,7 +2100,7 @@
           <a:p>
             <a:fld id="{708B7524-32A2-4C20-A58C-BC3BAA1042FC}" type="datetime1">
               <a:rPr lang="en-US" smtClean="0"/>
-              <a:t>8/27/2026</a:t>
+              <a:t>9/9/2026</a:t>
             </a:fld>
             <a:endParaRPr lang="en-US"/>
           </a:p>
@@ -2231,7 +2359,7 @@
           <a:p>
             <a:fld id="{1E994447-D6B2-43BB-A877-57F1A267B999}" type="datetime1">
               <a:rPr lang="en-US" smtClean="0"/>
-              <a:t>8/27/2026</a:t>
+              <a:t>9/9/2026</a:t>
             </a:fld>
             <a:endParaRPr lang="en-US"/>
           </a:p>
@@ -2530,7 +2658,7 @@
           <a:p>
             <a:fld id="{68920E16-BD35-483C-AA6B-346FC7E46DEA}" type="datetime1">
               <a:rPr lang="en-US" smtClean="0"/>
-              <a:t>8/27/2026</a:t>
+              <a:t>9/9/2026</a:t>
             </a:fld>
             <a:endParaRPr lang="en-US"/>
           </a:p>
@@ -2963,7 +3091,7 @@
           <a:p>
             <a:fld id="{2FEAC6F8-5103-4FC0-A69E-5C6AE6469DA8}" type="datetime1">
               <a:rPr lang="en-US" smtClean="0"/>
-              <a:t>8/27/2026</a:t>
+              <a:t>9/9/2026</a:t>
             </a:fld>
             <a:endParaRPr lang="en-US"/>
           </a:p>
@@ -3094,7 +3222,7 @@
           <a:p>
             <a:fld id="{C60C6921-0627-4C8F-83D5-0CF936D2FFDD}" type="datetime1">
               <a:rPr lang="en-US" smtClean="0"/>
-              <a:t>8/27/2026</a:t>
+              <a:t>9/9/2026</a:t>
             </a:fld>
             <a:endParaRPr lang="en-US"/>
           </a:p>
@@ -3203,7 +3331,7 @@
           <a:p>
             <a:fld id="{2FF08AD7-8103-40F8-983C-E2BA6BB9CBE0}" type="datetime1">
               <a:rPr lang="en-US" smtClean="0"/>
-              <a:t>8/27/2026</a:t>
+              <a:t>9/9/2026</a:t>
             </a:fld>
             <a:endParaRPr lang="en-US"/>
           </a:p>
@@ -3492,7 +3620,7 @@
           <a:p>
             <a:fld id="{DF8C06B4-9380-4A4D-AF49-A3596E17DAF5}" type="datetime1">
               <a:rPr lang="en-US" smtClean="0"/>
-              <a:t>8/27/2026</a:t>
+              <a:t>9/9/2026</a:t>
             </a:fld>
             <a:endParaRPr lang="en-US"/>
           </a:p>
@@ -3761,7 +3889,7 @@
           <a:p>
             <a:fld id="{EF7FDEF1-C582-4E22-9E77-D68326471F28}" type="datetime1">
               <a:rPr lang="en-US" smtClean="0"/>
-              <a:t>8/27/2026</a:t>
+              <a:t>9/9/2026</a:t>
             </a:fld>
             <a:endParaRPr lang="en-US"/>
           </a:p>
@@ -4004,7 +4132,7 @@
           <a:p>
             <a:fld id="{780A9602-A9A9-453F-AEF1-37B5837E02CD}" type="datetime1">
               <a:rPr lang="en-US" smtClean="0"/>
-              <a:t>8/27/2026</a:t>
+              <a:t>9/9/2026</a:t>
             </a:fld>
             <a:endParaRPr lang="en-US"/>
           </a:p>
@@ -4637,7 +4765,7 @@
         </p:nvSpPr>
         <p:spPr>
           <a:xfrm>
-            <a:off x="-1120165" y="-60468"/>
+            <a:off x="582341" y="161886"/>
             <a:ext cx="9448799" cy="1220789"/>
           </a:xfrm>
         </p:spPr>
@@ -4649,7 +4777,7 @@
               <a:rPr lang="en-US" sz="3200" b="1">
                 <a:latin typeface="Garamond" panose="02020404030301010803" pitchFamily="18" charset="0"/>
               </a:rPr>
-              <a:t>SMART INDIA HACKATHON 2025</a:t>
+              <a:t>SMART INDIA HACKATHON 2026</a:t>
             </a:r>
             <a:endParaRPr lang="en-IN" sz="3200" b="1">
               <a:latin typeface="Garamond" panose="02020404030301010803" pitchFamily="18" charset="0"/>
@@ -4953,7 +5081,7 @@
         </p:nvSpPr>
         <p:spPr>
           <a:xfrm>
-            <a:off x="7051873" y="1128242"/>
+            <a:off x="7071713" y="1160321"/>
             <a:ext cx="2084601" cy="2134565"/>
           </a:xfrm>
           <a:prstGeom prst="ellipse">
@@ -5088,53 +5216,6 @@
       </p:sp>
       <p:pic>
         <p:nvPicPr>
-          <p:cNvPr id="27" name="Picture 2" descr="https://www.sih.gov.in/img1/SIH-Logo.png">
-            <a:extLst>
-              <a:ext uri="{FF2B5EF4-FFF2-40B4-BE49-F238E27FC236}">
-                <a16:creationId xmlns:a16="http://schemas.microsoft.com/office/drawing/2014/main" id="{91A65FDF-306C-B479-F47E-C51593314478}"/>
-              </a:ext>
-            </a:extLst>
-          </p:cNvPr>
-          <p:cNvPicPr>
-            <a:picLocks noChangeAspect="1" noChangeArrowheads="1"/>
-          </p:cNvPicPr>
-          <p:nvPr/>
-        </p:nvPicPr>
-        <p:blipFill>
-          <a:blip r:embed="rId3">
-            <a:extLst>
-              <a:ext uri="{28A0092B-C50C-407E-A947-70E740481C1C}">
-                <a14:useLocalDpi xmlns:a14="http://schemas.microsoft.com/office/drawing/2010/main" val="0"/>
-              </a:ext>
-            </a:extLst>
-          </a:blip>
-          <a:srcRect/>
-          <a:stretch>
-            <a:fillRect/>
-          </a:stretch>
-        </p:blipFill>
-        <p:spPr bwMode="auto">
-          <a:xfrm>
-            <a:off x="7242531" y="1705252"/>
-            <a:ext cx="1742218" cy="885548"/>
-          </a:xfrm>
-          <a:prstGeom prst="rect">
-            <a:avLst/>
-          </a:prstGeom>
-          <a:noFill/>
-          <a:extLst>
-            <a:ext uri="{909E8E84-426E-40DD-AFC4-6F175D3DCCD1}">
-              <a14:hiddenFill xmlns:a14="http://schemas.microsoft.com/office/drawing/2010/main">
-                <a:solidFill>
-                  <a:srgbClr val="FFFFFF"/>
-                </a:solidFill>
-              </a14:hiddenFill>
-            </a:ext>
-          </a:extLst>
-        </p:spPr>
-      </p:pic>
-      <p:pic>
-        <p:nvPicPr>
           <p:cNvPr id="5" name="Picture 4">
             <a:extLst>
               <a:ext uri="{FF2B5EF4-FFF2-40B4-BE49-F238E27FC236}">
@@ -5148,7 +5229,7 @@
           <p:nvPr/>
         </p:nvPicPr>
         <p:blipFill rotWithShape="1">
-          <a:blip r:embed="rId4"/>
+          <a:blip r:embed="rId3"/>
           <a:srcRect r="59916"/>
           <a:stretch/>
         </p:blipFill>
@@ -5335,6 +5416,36 @@
           </a:p>
         </p:txBody>
       </p:sp>
+      <p:pic>
+        <p:nvPicPr>
+          <p:cNvPr id="4" name="Picture 3">
+            <a:extLst>
+              <a:ext uri="{FF2B5EF4-FFF2-40B4-BE49-F238E27FC236}">
+                <a16:creationId xmlns:a16="http://schemas.microsoft.com/office/drawing/2014/main" id="{A70D289A-766A-620B-85FD-871B699E31FA}"/>
+              </a:ext>
+            </a:extLst>
+          </p:cNvPr>
+          <p:cNvPicPr>
+            <a:picLocks noChangeAspect="1"/>
+          </p:cNvPicPr>
+          <p:nvPr/>
+        </p:nvPicPr>
+        <p:blipFill>
+          <a:blip r:embed="rId4"/>
+          <a:stretch>
+            <a:fillRect/>
+          </a:stretch>
+        </p:blipFill>
+        <p:spPr>
+          <a:xfrm>
+            <a:off x="7265498" y="1795174"/>
+            <a:ext cx="1657350" cy="919163"/>
+          </a:xfrm>
+          <a:prstGeom prst="rect">
+            <a:avLst/>
+          </a:prstGeom>
+        </p:spPr>
+      </p:pic>
     </p:spTree>
     <p:extLst>
       <p:ext uri="{BB962C8B-B14F-4D97-AF65-F5344CB8AC3E}">
@@ -5445,53 +5556,6 @@
           </a:p>
         </p:txBody>
       </p:sp>
-      <p:pic>
-        <p:nvPicPr>
-          <p:cNvPr id="4" name="Picture 2" descr="https://www.sih.gov.in/img1/SIH-Logo.png">
-            <a:extLst>
-              <a:ext uri="{FF2B5EF4-FFF2-40B4-BE49-F238E27FC236}">
-                <a16:creationId xmlns:a16="http://schemas.microsoft.com/office/drawing/2014/main" id="{676B2FE9-A35D-1AC7-65AB-8AD8AD09CB7C}"/>
-              </a:ext>
-            </a:extLst>
-          </p:cNvPr>
-          <p:cNvPicPr>
-            <a:picLocks noChangeAspect="1" noChangeArrowheads="1"/>
-          </p:cNvPicPr>
-          <p:nvPr/>
-        </p:nvPicPr>
-        <p:blipFill>
-          <a:blip r:embed="rId3">
-            <a:extLst>
-              <a:ext uri="{28A0092B-C50C-407E-A947-70E740481C1C}">
-                <a14:useLocalDpi xmlns:a14="http://schemas.microsoft.com/office/drawing/2010/main" val="0"/>
-              </a:ext>
-            </a:extLst>
-          </a:blip>
-          <a:srcRect/>
-          <a:stretch>
-            <a:fillRect/>
-          </a:stretch>
-        </p:blipFill>
-        <p:spPr bwMode="auto">
-          <a:xfrm>
-            <a:off x="10595331" y="84459"/>
-            <a:ext cx="1399445" cy="711321"/>
-          </a:xfrm>
-          <a:prstGeom prst="rect">
-            <a:avLst/>
-          </a:prstGeom>
-          <a:noFill/>
-          <a:extLst>
-            <a:ext uri="{909E8E84-426E-40DD-AFC4-6F175D3DCCD1}">
-              <a14:hiddenFill xmlns:a14="http://schemas.microsoft.com/office/drawing/2010/main">
-                <a:solidFill>
-                  <a:srgbClr val="FFFFFF"/>
-                </a:solidFill>
-              </a14:hiddenFill>
-            </a:ext>
-          </a:extLst>
-        </p:spPr>
-      </p:pic>
       <p:sp>
         <p:nvSpPr>
           <p:cNvPr id="7" name="Oval 6" descr="Your startup LOGO">
@@ -5621,12 +5685,13 @@
           <a:p>
             <a:pPr rtl="0">
               <a:buNone/>
+              <a:defRPr sz="1800" b="1">
+                <a:solidFill>
+                  <a:srgbClr val="0B0B0B"/>
+                </a:solidFill>
+              </a:defRPr>
             </a:pPr>
             <a:r>
-              <a:rPr lang="en-IN" sz="2400" b="1">
-                <a:latin typeface="Bell MT" panose="02020503060305020303" pitchFamily="18" charset="0"/>
-                <a:cs typeface="Times New Roman" panose="02020603050405020304" pitchFamily="18" charset="0"/>
-              </a:rPr>
               <a:t>Detailed explanation of the proposed solution:</a:t>
             </a:r>
             <a:endParaRPr lang="en-IN" sz="2400">
@@ -5635,143 +5700,145 @@
             </a:endParaRPr>
           </a:p>
           <a:p>
-            <a:pPr marL="342900" lvl="0" indent="-342900" rtl="0">
-              <a:buFont typeface="Arial" panose="020B0604020202020204" pitchFamily="34" charset="0"/>
-              <a:buChar char="•"/>
+            <a:pPr>
+              <a:defRPr sz="1300" b="0">
+                <a:solidFill>
+                  <a:srgbClr val="444441"/>
+                </a:solidFill>
+              </a:defRPr>
             </a:pPr>
             <a:r>
-              <a:rPr lang="en-IN"/>
-              <a:t>Offline app that grades diabetic retinopathy severity from fundus images (5 stages: No DR → Proliferative)</a:t>
-            </a:r>
-          </a:p>
-          <a:p>
-            <a:pPr marL="342900" lvl="0" indent="-342900" rtl="0">
-              <a:buFont typeface="Arial" panose="020B0604020202020204" pitchFamily="34" charset="0"/>
-              <a:buChar char="•"/>
+              <a:t>• Offline AI app that grades diabetic retinopathy severity from fundus images (5 stages: No DR → Proliferative)</a:t>
+            </a:r>
+          </a:p>
+          <a:p>
+            <a:pPr>
+              <a:defRPr sz="1300" b="0">
+                <a:solidFill>
+                  <a:srgbClr val="444441"/>
+                </a:solidFill>
+              </a:defRPr>
             </a:pPr>
             <a:r>
-              <a:rPr lang="en-IN"/>
-              <a:t>Grad-CAM heatmap overlay shows exactly which retinal region drove the diagnosis</a:t>
-            </a:r>
-          </a:p>
-          <a:p>
-            <a:pPr marL="342900" lvl="0" indent="-342900" rtl="0">
-              <a:buFont typeface="Arial" panose="020B0604020202020204" pitchFamily="34" charset="0"/>
-              <a:buChar char="•"/>
+              <a:t>• Real-time Grad-CAM heatmap overlay highlights the exact retinal lesions (microaneurysms, hemorrhages) driving diagnosis</a:t>
+            </a:r>
+          </a:p>
+          <a:p>
+            <a:pPr>
+              <a:defRPr sz="1300" b="0">
+                <a:solidFill>
+                  <a:srgbClr val="444441"/>
+                </a:solidFill>
+              </a:defRPr>
             </a:pPr>
             <a:r>
-              <a:rPr lang="en-IN"/>
-              <a:t>PyTorch (EfficientNet-B0 + pytorch-grad-cam) for the model, FastAPI + web app for the clinician UI</a:t>
-            </a:r>
-            <a:r>
-              <a:rPr lang="en-IN" err="1"/>
-              <a:t/>
-            </a:r>
-            <a:r>
-              <a:rPr lang="en-IN"/>
-              <a:t/>
-            </a:r>
-          </a:p>
-          <a:p>
-            <a:pPr marL="342900" lvl="0" indent="-342900" rtl="0">
-              <a:buFont typeface="Arial" panose="020B0604020202020204" pitchFamily="34" charset="0"/>
-              <a:buChar char="•"/>
+              <a:t>• PyTorch (EfficientNet-B0 + Grad-CAM) for AI inference, FastAPI backend, modern clinician UI</a:t>
+            </a:r>
+          </a:p>
+          <a:p>
+            <a:pPr>
+              <a:defRPr sz="600" b="0"/>
             </a:pPr>
-            <a:endParaRPr lang="en-IN"/>
-          </a:p>
-          <a:p>
-            <a:pPr rtl="0">
-              <a:buNone/>
+          </a:p>
+          <a:p>
+            <a:pPr>
+              <a:defRPr sz="1800" b="1">
+                <a:solidFill>
+                  <a:srgbClr val="0B0B0B"/>
+                </a:solidFill>
+              </a:defRPr>
             </a:pPr>
             <a:r>
-              <a:rPr lang="en-IN" sz="2400" b="1">
-                <a:latin typeface="Bell MT" panose="02020503060305020303" pitchFamily="18" charset="0"/>
-              </a:rPr>
               <a:t>How it addresses the problem:</a:t>
             </a:r>
-            <a:endParaRPr lang="en-IN" sz="2400">
-              <a:latin typeface="Bell MT" panose="02020503060305020303" pitchFamily="18" charset="0"/>
-            </a:endParaRPr>
-          </a:p>
-          <a:p>
-            <a:pPr marL="342900" lvl="0" indent="-342900" rtl="0">
-              <a:buFont typeface="Arial" panose="020B0604020202020204" pitchFamily="34" charset="0"/>
-              <a:buChar char="•"/>
+          </a:p>
+          <a:p>
+            <a:pPr>
+              <a:defRPr sz="1300" b="0">
+                <a:solidFill>
+                  <a:srgbClr val="444441"/>
+                </a:solidFill>
+              </a:defRPr>
             </a:pPr>
             <a:r>
-              <a:rPr lang="en-IN"/>
-              <a:t>Works with zero internet — built for rural PHCs and health camps</a:t>
-            </a:r>
-          </a:p>
-          <a:p>
-            <a:pPr marL="342900" lvl="0" indent="-342900" rtl="0">
-              <a:buFont typeface="Arial" panose="020B0604020202020204" pitchFamily="34" charset="0"/>
-              <a:buChar char="•"/>
+              <a:t>• Works 100% offline with zero internet dependency — purpose-built for rural PHCs and mobile health camps</a:t>
+            </a:r>
+          </a:p>
+          <a:p>
+            <a:pPr>
+              <a:defRPr sz="1300" b="0">
+                <a:solidFill>
+                  <a:srgbClr val="444441"/>
+                </a:solidFill>
+              </a:defRPr>
             </a:pPr>
             <a:r>
-              <a:rPr lang="en-IN"/>
-              <a:t>Cuts reliance on scarce ophthalmologists for first-level screening</a:t>
-            </a:r>
-          </a:p>
-          <a:p>
-            <a:pPr marL="342900" lvl="0" indent="-342900" rtl="0">
-              <a:buFont typeface="Arial" panose="020B0604020202020204" pitchFamily="34" charset="0"/>
-              <a:buChar char="•"/>
+              <a:t>• Cuts reliance on scarce ophthalmologists for first-level triage in underserved regions</a:t>
+            </a:r>
+          </a:p>
+          <a:p>
+            <a:pPr>
+              <a:defRPr sz="1300" b="0">
+                <a:solidFill>
+                  <a:srgbClr val="444441"/>
+                </a:solidFill>
+              </a:defRPr>
             </a:pPr>
             <a:r>
-              <a:rPr lang="en-IN"/>
-              <a:t>Visual explanation builds trust instead of a black-box output</a:t>
-            </a:r>
-          </a:p>
-          <a:p>
-            <a:pPr marL="342900" lvl="0" indent="-342900" rtl="0">
-              <a:buFont typeface="Arial" panose="020B0604020202020204" pitchFamily="34" charset="0"/>
-              <a:buChar char="•"/>
+              <a:t>• Visual explanation builds clinical trust over uninterpretable black-box predictions</a:t>
+            </a:r>
+          </a:p>
+          <a:p>
+            <a:pPr>
+              <a:defRPr sz="600" b="0"/>
             </a:pPr>
-            <a:endParaRPr lang="en-IN"/>
-          </a:p>
-          <a:p>
-            <a:pPr rtl="0">
-              <a:buNone/>
+          </a:p>
+          <a:p>
+            <a:pPr>
+              <a:defRPr sz="1800" b="1">
+                <a:solidFill>
+                  <a:srgbClr val="0B0B0B"/>
+                </a:solidFill>
+              </a:defRPr>
             </a:pPr>
             <a:r>
-              <a:rPr lang="en-IN" sz="2400" b="1">
-                <a:latin typeface="Bell MT" panose="02020503060305020303" pitchFamily="18" charset="0"/>
-              </a:rPr>
               <a:t>Innovation and uniqueness:</a:t>
             </a:r>
-            <a:endParaRPr lang="en-IN" sz="2400">
-              <a:latin typeface="Bell MT" panose="02020503060305020303" pitchFamily="18" charset="0"/>
-            </a:endParaRPr>
-          </a:p>
-          <a:p>
-            <a:pPr marL="342900" lvl="0" indent="-342900" rtl="0">
-              <a:buFont typeface="Arial" panose="020B0604020202020204" pitchFamily="34" charset="0"/>
-              <a:buChar char="•"/>
+          </a:p>
+          <a:p>
+            <a:pPr>
+              <a:defRPr sz="1300" b="0">
+                <a:solidFill>
+                  <a:srgbClr val="444441"/>
+                </a:solidFill>
+              </a:defRPr>
             </a:pPr>
             <a:r>
-              <a:rPr lang="en-IN"/>
-              <a:t>Explainability is core to the workflow, not an add-on</a:t>
-            </a:r>
-          </a:p>
-          <a:p>
-            <a:pPr marL="342900" lvl="0" indent="-342900" rtl="0">
-              <a:buFont typeface="Arial" panose="020B0604020202020204" pitchFamily="34" charset="0"/>
-              <a:buChar char="•"/>
+              <a:t>• Explainability is native to the screening workflow, not an afterthought</a:t>
+            </a:r>
+          </a:p>
+          <a:p>
+            <a:pPr>
+              <a:defRPr sz="1300" b="0">
+                <a:solidFill>
+                  <a:srgbClr val="444441"/>
+                </a:solidFill>
+              </a:defRPr>
             </a:pPr>
             <a:r>
-              <a:rPr lang="en-IN"/>
-              <a:t>PyTorch CV core following the standard CNN+Grad-CAM workflow + lightweight offline-ready deployment</a:t>
-            </a:r>
-          </a:p>
-          <a:p>
-            <a:pPr marL="342900" lvl="0" indent="-342900" rtl="0">
-              <a:buFont typeface="Arial" panose="020B0604020202020204" pitchFamily="34" charset="0"/>
-              <a:buChar char="•"/>
+              <a:t>• Lightweight CPU inference (~0.4s) — runs on basic clinic laptops without GPU requirements</a:t>
+            </a:r>
+          </a:p>
+          <a:p>
+            <a:pPr>
+              <a:defRPr sz="1300" b="0">
+                <a:solidFill>
+                  <a:srgbClr val="444441"/>
+                </a:solidFill>
+              </a:defRPr>
             </a:pPr>
             <a:r>
-              <a:rPr lang="en-IN"/>
-              <a:t>Batch-screening mode built for camp-style rural outreach</a:t>
+              <a:t>• High-throughput screening design: fast per-patient workflow (batch camp triage on roadmap)</a:t>
             </a:r>
           </a:p>
         </p:txBody>
@@ -5794,7 +5861,7 @@
           <a:blip>
             <a:extLst>
               <a:ext uri="{96DAC541-7B7A-43D3-8B79-37D633B846F1}">
-                <asvg:svgBlip xmlns:asvg="http://schemas.microsoft.com/office/drawing/2016/SVG/main" r:embed="rId4"/>
+                <asvg:svgBlip xmlns:asvg="http://schemas.microsoft.com/office/drawing/2016/SVG/main" r:embed="rId3"/>
               </a:ext>
             </a:extLst>
           </a:blip>
@@ -5830,7 +5897,7 @@
           <a:blip>
             <a:extLst>
               <a:ext uri="{96DAC541-7B7A-43D3-8B79-37D633B846F1}">
-                <asvg:svgBlip xmlns:asvg="http://schemas.microsoft.com/office/drawing/2016/SVG/main" r:embed="rId5"/>
+                <asvg:svgBlip xmlns:asvg="http://schemas.microsoft.com/office/drawing/2016/SVG/main" r:embed="rId4"/>
               </a:ext>
             </a:extLst>
           </a:blip>
@@ -5842,6 +5909,36 @@
           <a:xfrm>
             <a:off x="7167223" y="3964446"/>
             <a:ext cx="5186905" cy="2288340"/>
+          </a:xfrm>
+          <a:prstGeom prst="rect">
+            <a:avLst/>
+          </a:prstGeom>
+        </p:spPr>
+      </p:pic>
+      <p:pic>
+        <p:nvPicPr>
+          <p:cNvPr id="3" name="Picture 2">
+            <a:extLst>
+              <a:ext uri="{FF2B5EF4-FFF2-40B4-BE49-F238E27FC236}">
+                <a16:creationId xmlns:a16="http://schemas.microsoft.com/office/drawing/2014/main" id="{81E66511-69DB-7291-3CDC-C34164EFC093}"/>
+              </a:ext>
+            </a:extLst>
+          </p:cNvPr>
+          <p:cNvPicPr>
+            <a:picLocks noChangeAspect="1"/>
+          </p:cNvPicPr>
+          <p:nvPr/>
+        </p:nvPicPr>
+        <p:blipFill>
+          <a:blip r:embed="rId5"/>
+          <a:stretch>
+            <a:fillRect/>
+          </a:stretch>
+        </p:blipFill>
+        <p:spPr>
+          <a:xfrm>
+            <a:off x="10534650" y="154222"/>
+            <a:ext cx="1657350" cy="919163"/>
           </a:xfrm>
           <a:prstGeom prst="rect">
             <a:avLst/>
@@ -5958,53 +6055,6 @@
           </a:p>
         </p:txBody>
       </p:sp>
-      <p:pic>
-        <p:nvPicPr>
-          <p:cNvPr id="4" name="Picture 2" descr="https://www.sih.gov.in/img1/SIH-Logo.png">
-            <a:extLst>
-              <a:ext uri="{FF2B5EF4-FFF2-40B4-BE49-F238E27FC236}">
-                <a16:creationId xmlns:a16="http://schemas.microsoft.com/office/drawing/2014/main" id="{645E8022-BE84-3606-0D19-6F54D8DB70DA}"/>
-              </a:ext>
-            </a:extLst>
-          </p:cNvPr>
-          <p:cNvPicPr>
-            <a:picLocks noChangeAspect="1" noChangeArrowheads="1"/>
-          </p:cNvPicPr>
-          <p:nvPr/>
-        </p:nvPicPr>
-        <p:blipFill>
-          <a:blip r:embed="rId3">
-            <a:extLst>
-              <a:ext uri="{28A0092B-C50C-407E-A947-70E740481C1C}">
-                <a14:useLocalDpi xmlns:a14="http://schemas.microsoft.com/office/drawing/2010/main" val="0"/>
-              </a:ext>
-            </a:extLst>
-          </a:blip>
-          <a:srcRect/>
-          <a:stretch>
-            <a:fillRect/>
-          </a:stretch>
-        </p:blipFill>
-        <p:spPr bwMode="auto">
-          <a:xfrm>
-            <a:off x="10595331" y="84459"/>
-            <a:ext cx="1399445" cy="711321"/>
-          </a:xfrm>
-          <a:prstGeom prst="rect">
-            <a:avLst/>
-          </a:prstGeom>
-          <a:noFill/>
-          <a:extLst>
-            <a:ext uri="{909E8E84-426E-40DD-AFC4-6F175D3DCCD1}">
-              <a14:hiddenFill xmlns:a14="http://schemas.microsoft.com/office/drawing/2010/main">
-                <a:solidFill>
-                  <a:srgbClr val="FFFFFF"/>
-                </a:solidFill>
-              </a14:hiddenFill>
-            </a:ext>
-          </a:extLst>
-        </p:spPr>
-      </p:pic>
       <p:sp>
         <p:nvSpPr>
           <p:cNvPr id="7" name="Oval 6" descr="Your startup LOGO">
@@ -6102,12 +6152,119 @@
           </a:p>
         </p:txBody>
       </p:sp>
+      <p:sp>
+        <p:nvSpPr>
+          <p:cNvPr id="16" name="TextBox 15">
+            <a:extLst>
+              <a:ext uri="{FF2B5EF4-FFF2-40B4-BE49-F238E27FC236}">
+                <a16:creationId xmlns:a16="http://schemas.microsoft.com/office/drawing/2014/main" id="{78943C23-1BD2-3379-5A8C-7334E1BB3DF8}"/>
+              </a:ext>
+            </a:extLst>
+          </p:cNvPr>
+          <p:cNvSpPr txBox="1"/>
+          <p:nvPr/>
+        </p:nvSpPr>
+        <p:spPr>
+          <a:xfrm>
+            <a:off x="250000" y="1450000"/>
+            <a:ext cx="4450000" cy="4950000"/>
+          </a:xfrm>
+          <a:prstGeom prst="rect">
+            <a:avLst/>
+          </a:prstGeom>
+          <a:noFill/>
+        </p:spPr>
+        <p:txBody>
+          <a:bodyPr wrap="square">
+            <a:spAutoFit/>
+          </a:bodyPr>
+          <a:lstStyle/>
+          <a:p>
+            <a:pPr lvl="0">
+              <a:defRPr sz="1250"/>
+            </a:pPr>
+            <a:r>
+              <a:rPr lang="en-IN" sz="1200" b="1"/>
+              <a:t>Model:</a:t>
+            </a:r>
+            <a:r>
+              <a:rPr lang="en-IN" sz="1200"/>
+              <a:t> EfficientNet-B0 (ImageNet-pretrained), fine-tuned end-to-end for 5-class DR severity classification.</a:t>
+            </a:r>
+          </a:p>
+          <a:p>
+            <a:pPr lvl="0">
+              <a:defRPr sz="1250"/>
+            </a:pPr>
+            <a:r>
+              <a:rPr lang="en-IN" sz="1200" b="1"/>
+              <a:t>Explainability:</a:t>
+            </a:r>
+            <a:r>
+              <a:rPr lang="en-IN" sz="1200"/>
+              <a:t> Grad-CAM, computed on the final convolutional block, to generate lesion-localizing heatmaps.</a:t>
+            </a:r>
+          </a:p>
+          <a:p>
+            <a:pPr lvl="0">
+              <a:defRPr sz="1250"/>
+            </a:pPr>
+            <a:r>
+              <a:rPr lang="en-IN" sz="1200" b="1"/>
+              <a:t>Preprocessing:</a:t>
+            </a:r>
+            <a:r>
+              <a:rPr lang="en-IN" sz="1200"/>
+              <a:t> CLAHE (Contrast Limited Adaptive Histogram Equalization) + crop + resize to 224×224 RGB, to normalize the wide variation in fundus image lighting/contrast seen across cameras.</a:t>
+            </a:r>
+          </a:p>
+          <a:p>
+            <a:pPr lvl="0">
+              <a:defRPr sz="1250"/>
+            </a:pPr>
+            <a:r>
+              <a:rPr lang="en-IN" sz="1200" b="1"/>
+              <a:t>Backend:</a:t>
+            </a:r>
+            <a:r>
+              <a:rPr lang="en-IN" sz="1200"/>
+              <a:t> FastAPI serving a single /predict endpoint — accepts a multipart image upload and returns the severity grade, per-class confidence scores, the processed image, and the heatmap overlay as a JSON response. The model checkpoint loads once at startup and stays in memory, avoiding repeated disk I/O per request.</a:t>
+            </a:r>
+          </a:p>
+          <a:p>
+            <a:pPr lvl="0">
+              <a:defRPr sz="1250"/>
+            </a:pPr>
+            <a:r>
+              <a:rPr lang="en-IN" sz="1200" b="1"/>
+              <a:t>Frontend:</a:t>
+            </a:r>
+            <a:r>
+              <a:rPr lang="en-IN" sz="1200"/>
+              <a:t> A single-file HTML/JS interface — no build pipeline — so the demo can run on any machine with a browser.</a:t>
+            </a:r>
+          </a:p>
+          <a:p>
+            <a:pPr lvl="0">
+              <a:defRPr sz="1250"/>
+            </a:pPr>
+            <a:r>
+              <a:rPr lang="en-IN" sz="1200" b="1"/>
+              <a:t>Class-imbalance handling:</a:t>
+            </a:r>
+            <a:r>
+              <a:rPr lang="en-IN" sz="1200"/>
+              <a:t> weighted cross-entropy loss, with class weights computed from the training distribution, since DR datasets are naturally skewed toward "No DR" cases.</a:t>
+            </a:r>
+          </a:p>
+        </p:txBody>
+      </p:sp>
       <p:pic>
         <p:nvPicPr>
-          <p:cNvPr id="6" name="Graphic 5">
+          <p:cNvPr id="9" name="Picture 8">
             <a:extLst>
               <a:ext uri="{FF2B5EF4-FFF2-40B4-BE49-F238E27FC236}">
-                <a16:creationId xmlns:a16="http://schemas.microsoft.com/office/drawing/2014/main" id="{2A635344-5E46-87A1-2FEC-4C73CFA5B071}"/>
+                <a16:creationId xmlns:a16="http://schemas.microsoft.com/office/drawing/2014/main" id="{6D0D0099-7BE6-5418-9B08-2D2D84B17565}"/>
               </a:ext>
             </a:extLst>
           </p:cNvPr>
@@ -6117,10 +6274,34 @@
           <p:nvPr/>
         </p:nvPicPr>
         <p:blipFill>
+          <a:blip r:embed="rId3"/>
+          <a:stretch>
+            <a:fillRect/>
+          </a:stretch>
+        </p:blipFill>
+        <p:spPr>
+          <a:xfrm>
+            <a:off x="10534650" y="154222"/>
+            <a:ext cx="1657350" cy="919163"/>
+          </a:xfrm>
+          <a:prstGeom prst="rect">
+            <a:avLst/>
+          </a:prstGeom>
+        </p:spPr>
+      </p:pic>
+      <p:pic xmlns:p="http://schemas.openxmlformats.org/presentationml/2006/main" xmlns:a="http://schemas.openxmlformats.org/drawingml/2006/main" xmlns:r="http://schemas.openxmlformats.org/officeDocument/2006/relationships" xmlns:asvg="http://schemas.microsoft.com/office/drawing/2016/SVG/main">
+        <p:nvPicPr>
+          <p:cNvPr id="50" name="Graphic Pipeline"/>
+          <p:cNvPicPr>
+            <a:picLocks noChangeAspect="1"/>
+          </p:cNvPicPr>
+          <p:nvPr/>
+        </p:nvPicPr>
+        <p:blipFill>
           <a:blip>
             <a:extLst>
               <a:ext uri="{96DAC541-7B7A-43D3-8B79-37D633B846F1}">
-                <asvg:svgBlip xmlns:asvg="http://schemas.microsoft.com/office/drawing/2016/SVG/main" r:embed="rId4"/>
+                <asvg:svgBlip r:embed="rId4"/>
               </a:ext>
             </a:extLst>
           </a:blip>
@@ -6130,124 +6311,8 @@
         </p:blipFill>
         <p:spPr>
           <a:xfrm>
-            <a:off x="5894521" y="2404826"/>
-            <a:ext cx="6477000" cy="4095750"/>
-          </a:xfrm>
-          <a:prstGeom prst="rect">
-            <a:avLst/>
-          </a:prstGeom>
-        </p:spPr>
-      </p:pic>
-      <p:sp>
-        <p:nvSpPr>
-          <p:cNvPr id="16" name="TextBox 15">
-            <a:extLst>
-              <a:ext uri="{FF2B5EF4-FFF2-40B4-BE49-F238E27FC236}">
-                <a16:creationId xmlns:a16="http://schemas.microsoft.com/office/drawing/2014/main" id="{78943C23-1BD2-3379-5A8C-7334E1BB3DF8}"/>
-              </a:ext>
-            </a:extLst>
-          </p:cNvPr>
-          <p:cNvSpPr txBox="1"/>
-          <p:nvPr/>
-        </p:nvSpPr>
-        <p:spPr>
-          <a:xfrm>
-            <a:off x="2246694" y="2008517"/>
-            <a:ext cx="1911199" cy="461665"/>
-          </a:xfrm>
-          <a:prstGeom prst="rect">
-            <a:avLst/>
-          </a:prstGeom>
-          <a:noFill/>
-        </p:spPr>
-        <p:txBody>
-          <a:bodyPr wrap="square">
-            <a:spAutoFit/>
-          </a:bodyPr>
-          <a:lstStyle/>
-          <a:p>
-            <a:r>
-              <a:rPr lang="en-US" sz="2400">
-                <a:latin typeface="Bell MT" panose="02020503060305020303" pitchFamily="18" charset="0"/>
-              </a:rPr>
-              <a:t>Technologies</a:t>
-            </a:r>
-            <a:endParaRPr lang="en-IN" sz="2400">
-              <a:latin typeface="Bell MT" panose="02020503060305020303" pitchFamily="18" charset="0"/>
-            </a:endParaRPr>
-          </a:p>
-        </p:txBody>
-      </p:sp>
-      <p:sp>
-        <p:nvSpPr>
-          <p:cNvPr id="19" name="TextBox 18">
-            <a:extLst>
-              <a:ext uri="{FF2B5EF4-FFF2-40B4-BE49-F238E27FC236}">
-                <a16:creationId xmlns:a16="http://schemas.microsoft.com/office/drawing/2014/main" id="{00E1D1FF-0706-497D-BB82-D470B4C5049C}"/>
-              </a:ext>
-            </a:extLst>
-          </p:cNvPr>
-          <p:cNvSpPr txBox="1"/>
-          <p:nvPr/>
-        </p:nvSpPr>
-        <p:spPr>
-          <a:xfrm>
-            <a:off x="8195880" y="1978455"/>
-            <a:ext cx="1911199" cy="461665"/>
-          </a:xfrm>
-          <a:prstGeom prst="rect">
-            <a:avLst/>
-          </a:prstGeom>
-          <a:noFill/>
-        </p:spPr>
-        <p:txBody>
-          <a:bodyPr wrap="square">
-            <a:spAutoFit/>
-          </a:bodyPr>
-          <a:lstStyle/>
-          <a:p>
-            <a:r>
-              <a:rPr lang="en-US" sz="2400">
-                <a:latin typeface="Bell MT" panose="02020503060305020303" pitchFamily="18" charset="0"/>
-              </a:rPr>
-              <a:t>Methodology</a:t>
-            </a:r>
-            <a:endParaRPr lang="en-IN" sz="2400">
-              <a:latin typeface="Bell MT" panose="02020503060305020303" pitchFamily="18" charset="0"/>
-            </a:endParaRPr>
-          </a:p>
-        </p:txBody>
-      </p:sp>
-      <p:pic>
-        <p:nvPicPr>
-          <p:cNvPr id="3" name="Graphic 2">
-            <a:extLst>
-              <a:ext uri="{FF2B5EF4-FFF2-40B4-BE49-F238E27FC236}">
-                <a16:creationId xmlns:a16="http://schemas.microsoft.com/office/drawing/2014/main" id="{E2BCF975-0AD4-867F-648C-3BBEBE5716F8}"/>
-              </a:ext>
-            </a:extLst>
-          </p:cNvPr>
-          <p:cNvPicPr>
-            <a:picLocks noChangeAspect="1"/>
-          </p:cNvPicPr>
-          <p:nvPr/>
-        </p:nvPicPr>
-        <p:blipFill>
-          <a:blip>
-            <a:extLst>
-              <a:ext uri="{96DAC541-7B7A-43D3-8B79-37D633B846F1}">
-                <asvg:svgBlip xmlns:asvg="http://schemas.microsoft.com/office/drawing/2016/SVG/main" r:embed="rId5"/>
-              </a:ext>
-            </a:extLst>
-          </a:blip>
-          <a:stretch>
-            <a:fillRect/>
-          </a:stretch>
-        </p:blipFill>
-        <p:spPr>
-          <a:xfrm>
-            <a:off x="-125946" y="2605261"/>
-            <a:ext cx="6386508" cy="3418660"/>
+            <a:off x="4800000" y="1350000"/>
+            <a:ext cx="7000000" cy="5147000"/>
           </a:xfrm>
           <a:prstGeom prst="rect">
             <a:avLst/>
@@ -6364,53 +6429,6 @@
           </a:p>
         </p:txBody>
       </p:sp>
-      <p:pic>
-        <p:nvPicPr>
-          <p:cNvPr id="4" name="Picture 2" descr="https://www.sih.gov.in/img1/SIH-Logo.png">
-            <a:extLst>
-              <a:ext uri="{FF2B5EF4-FFF2-40B4-BE49-F238E27FC236}">
-                <a16:creationId xmlns:a16="http://schemas.microsoft.com/office/drawing/2014/main" id="{AC5F0E2C-E14D-28DB-24D4-D46BC489E66E}"/>
-              </a:ext>
-            </a:extLst>
-          </p:cNvPr>
-          <p:cNvPicPr>
-            <a:picLocks noChangeAspect="1" noChangeArrowheads="1"/>
-          </p:cNvPicPr>
-          <p:nvPr/>
-        </p:nvPicPr>
-        <p:blipFill>
-          <a:blip r:embed="rId3">
-            <a:extLst>
-              <a:ext uri="{28A0092B-C50C-407E-A947-70E740481C1C}">
-                <a14:useLocalDpi xmlns:a14="http://schemas.microsoft.com/office/drawing/2010/main" val="0"/>
-              </a:ext>
-            </a:extLst>
-          </a:blip>
-          <a:srcRect/>
-          <a:stretch>
-            <a:fillRect/>
-          </a:stretch>
-        </p:blipFill>
-        <p:spPr bwMode="auto">
-          <a:xfrm>
-            <a:off x="10595331" y="84459"/>
-            <a:ext cx="1399445" cy="711321"/>
-          </a:xfrm>
-          <a:prstGeom prst="rect">
-            <a:avLst/>
-          </a:prstGeom>
-          <a:noFill/>
-          <a:extLst>
-            <a:ext uri="{909E8E84-426E-40DD-AFC4-6F175D3DCCD1}">
-              <a14:hiddenFill xmlns:a14="http://schemas.microsoft.com/office/drawing/2010/main">
-                <a:solidFill>
-                  <a:srgbClr val="FFFFFF"/>
-                </a:solidFill>
-              </a14:hiddenFill>
-            </a:ext>
-          </a:extLst>
-        </p:spPr>
-      </p:pic>
       <p:sp>
         <p:nvSpPr>
           <p:cNvPr id="7" name="Oval 6" descr="Your startup LOGO">
@@ -6505,98 +6523,6 @@
       </p:sp>
       <p:sp>
         <p:nvSpPr>
-          <p:cNvPr id="16" name="TextBox 15">
-            <a:extLst>
-              <a:ext uri="{FF2B5EF4-FFF2-40B4-BE49-F238E27FC236}">
-                <a16:creationId xmlns:a16="http://schemas.microsoft.com/office/drawing/2014/main" id="{66F8B25A-96E6-7BC9-A80F-1C2E4558AF7B}"/>
-              </a:ext>
-            </a:extLst>
-          </p:cNvPr>
-          <p:cNvSpPr txBox="1"/>
-          <p:nvPr/>
-        </p:nvSpPr>
-        <p:spPr>
-          <a:xfrm>
-            <a:off x="2164690" y="2036560"/>
-            <a:ext cx="1911199" cy="461665"/>
-          </a:xfrm>
-          <a:prstGeom prst="rect">
-            <a:avLst/>
-          </a:prstGeom>
-          <a:noFill/>
-        </p:spPr>
-        <p:txBody>
-          <a:bodyPr wrap="square">
-            <a:spAutoFit/>
-          </a:bodyPr>
-          <a:lstStyle/>
-          <a:p>
-            <a:r>
-              <a:rPr lang="en-US" sz="2400">
-                <a:solidFill>
-                  <a:schemeClr val="bg1"/>
-                </a:solidFill>
-                <a:latin typeface="Bell MT" panose="02020503060305020303" pitchFamily="18" charset="0"/>
-              </a:rPr>
-              <a:t>Technologies</a:t>
-            </a:r>
-            <a:endParaRPr lang="en-IN" sz="2400">
-              <a:solidFill>
-                <a:schemeClr val="bg1"/>
-              </a:solidFill>
-              <a:latin typeface="Bell MT" panose="02020503060305020303" pitchFamily="18" charset="0"/>
-            </a:endParaRPr>
-          </a:p>
-        </p:txBody>
-      </p:sp>
-      <p:sp>
-        <p:nvSpPr>
-          <p:cNvPr id="19" name="TextBox 18">
-            <a:extLst>
-              <a:ext uri="{FF2B5EF4-FFF2-40B4-BE49-F238E27FC236}">
-                <a16:creationId xmlns:a16="http://schemas.microsoft.com/office/drawing/2014/main" id="{BBEC893D-D250-45CF-298E-D4C3B00347C9}"/>
-              </a:ext>
-            </a:extLst>
-          </p:cNvPr>
-          <p:cNvSpPr txBox="1"/>
-          <p:nvPr/>
-        </p:nvSpPr>
-        <p:spPr>
-          <a:xfrm>
-            <a:off x="8195880" y="1978455"/>
-            <a:ext cx="1911199" cy="461665"/>
-          </a:xfrm>
-          <a:prstGeom prst="rect">
-            <a:avLst/>
-          </a:prstGeom>
-          <a:noFill/>
-        </p:spPr>
-        <p:txBody>
-          <a:bodyPr wrap="square">
-            <a:spAutoFit/>
-          </a:bodyPr>
-          <a:lstStyle/>
-          <a:p>
-            <a:r>
-              <a:rPr lang="en-US" sz="2400">
-                <a:solidFill>
-                  <a:schemeClr val="bg1"/>
-                </a:solidFill>
-                <a:latin typeface="Bell MT" panose="02020503060305020303" pitchFamily="18" charset="0"/>
-              </a:rPr>
-              <a:t>Methodology</a:t>
-            </a:r>
-            <a:endParaRPr lang="en-IN" sz="2400">
-              <a:solidFill>
-                <a:schemeClr val="bg1"/>
-              </a:solidFill>
-              <a:latin typeface="Bell MT" panose="02020503060305020303" pitchFamily="18" charset="0"/>
-            </a:endParaRPr>
-          </a:p>
-        </p:txBody>
-      </p:sp>
-      <p:sp>
-        <p:nvSpPr>
           <p:cNvPr id="10" name="TextBox 9">
             <a:extLst>
               <a:ext uri="{FF2B5EF4-FFF2-40B4-BE49-F238E27FC236}">
@@ -6628,15 +6554,13 @@
                 <a:spcPct val="100000"/>
               </a:lnSpc>
               <a:buNone/>
+              <a:defRPr sz="1700" b="1">
+                <a:solidFill>
+                  <a:srgbClr val="0B0B0B"/>
+                </a:solidFill>
+              </a:defRPr>
             </a:pPr>
             <a:r>
-              <a:rPr lang="en-IN" sz="2400" b="1" i="0">
-                <a:solidFill>
-                  <a:schemeClr val="tx1"/>
-                </a:solidFill>
-                <a:effectLst/>
-                <a:latin typeface="Bell MT" panose="02020503060305020303" pitchFamily="18" charset="0"/>
-              </a:rPr>
               <a:t>Feasibility:</a:t>
             </a:r>
             <a:endParaRPr lang="en-IN" sz="2400" b="0" i="0">
@@ -6648,288 +6572,170 @@
             </a:endParaRPr>
           </a:p>
           <a:p>
-            <a:pPr marL="342900" marR="0" lvl="0" indent="-342900" algn="l" rtl="0">
-              <a:lnSpc>
-                <a:spcPct val="100000"/>
-              </a:lnSpc>
-              <a:buFont typeface="Arial" panose="020B0604020202020204" pitchFamily="34" charset="0"/>
-              <a:buChar char="•"/>
+            <a:pPr>
+              <a:defRPr sz="1250" b="0">
+                <a:solidFill>
+                  <a:srgbClr val="444441"/>
+                </a:solidFill>
+              </a:defRPr>
             </a:pPr>
             <a:r>
-              <a:rPr lang="en-IN" sz="1800" b="0" i="0">
+              <a:t>• Proven deep learning architecture (EfficientNet-B0 + Grad-CAM)</a:t>
+            </a:r>
+          </a:p>
+          <a:p>
+            <a:pPr>
+              <a:defRPr sz="1250" b="0">
                 <a:solidFill>
-                  <a:schemeClr val="tx1"/>
+                  <a:srgbClr val="444441"/>
                 </a:solidFill>
-                <a:effectLst/>
-                <a:latin typeface="Calibri" pitchFamily="34" charset="0"/>
-              </a:rPr>
-              <a:t>Proven tech (CNN + Grad-CAM), public dataset ready, mature Python ML ecosystem speeds up build, low-hardware offline deployment</a:t>
-            </a:r>
-          </a:p>
-          <a:p>
-            <a:pPr marL="342900" marR="0" lvl="0" indent="-342900" algn="l" rtl="0">
-              <a:lnSpc>
-                <a:spcPct val="100000"/>
-              </a:lnSpc>
-              <a:buFont typeface="Arial" panose="020B0604020202020204" pitchFamily="34" charset="0"/>
-              <a:buChar char="•"/>
+              </a:defRPr>
             </a:pPr>
-            <a:endParaRPr lang="en-IN" sz="2000" b="0" i="0">
-              <a:solidFill>
-                <a:schemeClr val="tx1"/>
-              </a:solidFill>
-              <a:effectLst/>
-              <a:latin typeface="Bell MT" panose="02020503060305020303" pitchFamily="18" charset="0"/>
-            </a:endParaRPr>
-          </a:p>
-          <a:p>
-            <a:pPr marL="0" marR="0" indent="0" algn="l" rtl="0">
-              <a:lnSpc>
-                <a:spcPct val="100000"/>
-              </a:lnSpc>
-              <a:buNone/>
+            <a:r>
+              <a:t>• Validated on APTOS 2019 benchmark dataset across all 5 severity stages</a:t>
+            </a:r>
+          </a:p>
+          <a:p>
+            <a:pPr>
+              <a:defRPr sz="1250" b="0">
+                <a:solidFill>
+                  <a:srgbClr val="444441"/>
+                </a:solidFill>
+              </a:defRPr>
             </a:pPr>
             <a:r>
-              <a:rPr lang="en-IN" sz="2400" b="1" i="0">
+              <a:t>• Lightweight PyTorch CPU architecture, low-hardware offline deployment</a:t>
+            </a:r>
+          </a:p>
+          <a:p>
+            <a:pPr>
+              <a:defRPr sz="500" b="0"/>
+            </a:pPr>
+          </a:p>
+          <a:p>
+            <a:pPr>
+              <a:defRPr sz="1700" b="1">
                 <a:solidFill>
-                  <a:schemeClr val="tx1"/>
+                  <a:srgbClr val="0B0B0B"/>
                 </a:solidFill>
-                <a:effectLst/>
-                <a:latin typeface="Bell MT" panose="02020503060305020303" pitchFamily="18" charset="0"/>
-              </a:rPr>
+              </a:defRPr>
+            </a:pPr>
+            <a:r>
               <a:t>Challenges and risks:</a:t>
             </a:r>
-            <a:endParaRPr lang="en-IN" sz="2400" b="0" i="0">
-              <a:solidFill>
-                <a:schemeClr val="tx1"/>
-              </a:solidFill>
-              <a:effectLst/>
-              <a:latin typeface="Bell MT" panose="02020503060305020303" pitchFamily="18" charset="0"/>
-            </a:endParaRPr>
-          </a:p>
-          <a:p>
-            <a:pPr marL="342900" marR="0" lvl="0" indent="-342900" algn="l" rtl="0">
-              <a:lnSpc>
-                <a:spcPct val="100000"/>
-              </a:lnSpc>
-              <a:buFont typeface="Arial" panose="020B0604020202020204" pitchFamily="34" charset="0"/>
-              <a:buChar char="•"/>
+          </a:p>
+          <a:p>
+            <a:pPr>
+              <a:defRPr sz="1250" b="0">
+                <a:solidFill>
+                  <a:srgbClr val="444441"/>
+                </a:solidFill>
+              </a:defRPr>
             </a:pPr>
             <a:r>
-              <a:rPr lang="en-IN" sz="1800" b="0" i="0">
+              <a:t>• Severe class imbalance (preponderance of "No DR" cases)</a:t>
+            </a:r>
+          </a:p>
+          <a:p>
+            <a:pPr>
+              <a:defRPr sz="1250" b="0">
                 <a:solidFill>
-                  <a:schemeClr val="tx1"/>
+                  <a:srgbClr val="444441"/>
                 </a:solidFill>
-                <a:effectLst/>
-                <a:latin typeface="Calibri" pitchFamily="34" charset="0"/>
-              </a:rPr>
-              <a:t>Class imbalance (mostly "No DR" images)</a:t>
-            </a:r>
-          </a:p>
-          <a:p>
-            <a:pPr marL="342900" marR="0" lvl="0" indent="-342900" algn="l" rtl="0">
-              <a:lnSpc>
-                <a:spcPct val="100000"/>
-              </a:lnSpc>
-              <a:buFont typeface="Arial" panose="020B0604020202020204" pitchFamily="34" charset="0"/>
-              <a:buChar char="•"/>
+              </a:defRPr>
             </a:pPr>
             <a:r>
-              <a:rPr lang="en-IN" sz="1800" b="0" i="0">
+              <a:t>• Variable field image quality &amp; illumination from rural cameras</a:t>
+            </a:r>
+          </a:p>
+          <a:p>
+            <a:pPr>
+              <a:defRPr sz="1250" b="0">
                 <a:solidFill>
-                  <a:schemeClr val="tx1"/>
+                  <a:srgbClr val="444441"/>
                 </a:solidFill>
-                <a:effectLst/>
-                <a:latin typeface="Calibri" pitchFamily="34" charset="0"/>
-              </a:rPr>
-              <a:t>Real-world image quality varies from clean training data</a:t>
-            </a:r>
-          </a:p>
-          <a:p>
-            <a:pPr marL="342900" marR="0" lvl="0" indent="-342900" algn="l" rtl="0">
-              <a:lnSpc>
-                <a:spcPct val="100000"/>
-              </a:lnSpc>
-              <a:buFont typeface="Arial" panose="020B0604020202020204" pitchFamily="34" charset="0"/>
-              <a:buChar char="•"/>
+              </a:defRPr>
             </a:pPr>
             <a:r>
-              <a:rPr lang="en-IN" sz="1800" b="0" i="0">
+              <a:t>• Saliency heatmaps must correlate with true ophthalmological lesions</a:t>
+            </a:r>
+          </a:p>
+          <a:p>
+            <a:pPr>
+              <a:defRPr sz="1250" b="0">
                 <a:solidFill>
-                  <a:schemeClr val="tx1"/>
+                  <a:srgbClr val="444441"/>
                 </a:solidFill>
-                <a:effectLst/>
-                <a:latin typeface="Calibri" pitchFamily="34" charset="0"/>
-              </a:rPr>
-              <a:t>Heatmaps can look right but be clinically wrong</a:t>
-            </a:r>
-          </a:p>
-          <a:p>
-            <a:pPr marL="342900" marR="0" lvl="0" indent="-342900" algn="l" rtl="0">
-              <a:lnSpc>
-                <a:spcPct val="100000"/>
-              </a:lnSpc>
-              <a:buFont typeface="Arial" panose="020B0604020202020204" pitchFamily="34" charset="0"/>
-              <a:buChar char="•"/>
+              </a:defRPr>
             </a:pPr>
             <a:r>
-              <a:rPr lang="en-IN" sz="1800" b="0" i="0">
+              <a:t>• Critical clinical risk: false negatives on sight-threatening cases</a:t>
+            </a:r>
+          </a:p>
+          <a:p>
+            <a:pPr>
+              <a:defRPr sz="500" b="0"/>
+            </a:pPr>
+          </a:p>
+          <a:p>
+            <a:pPr>
+              <a:defRPr sz="1700" b="1">
                 <a:solidFill>
-                  <a:schemeClr val="tx1"/>
+                  <a:srgbClr val="0B0B0B"/>
                 </a:solidFill>
-                <a:effectLst/>
-                <a:latin typeface="Calibri" pitchFamily="34" charset="0"/>
-              </a:rPr>
-              <a:t>False negatives on severe cases are dangerous</a:t>
-            </a:r>
-          </a:p>
-          <a:p>
-            <a:pPr marL="342900" marR="0" lvl="0" indent="-342900" algn="l" rtl="0">
-              <a:lnSpc>
-                <a:spcPct val="100000"/>
-              </a:lnSpc>
-              <a:buFont typeface="Arial" panose="020B0604020202020204" pitchFamily="34" charset="0"/>
-              <a:buChar char="•"/>
+              </a:defRPr>
             </a:pPr>
-            <a:endParaRPr lang="en-IN" sz="1800" b="0" i="0">
-              <a:solidFill>
-                <a:schemeClr val="tx1"/>
-              </a:solidFill>
-              <a:effectLst/>
-              <a:latin typeface="Calibri" pitchFamily="34" charset="0"/>
-            </a:endParaRPr>
-          </a:p>
-          <a:p>
-            <a:pPr marL="0" marR="0" indent="0" algn="l" rtl="0">
-              <a:lnSpc>
-                <a:spcPct val="100000"/>
-              </a:lnSpc>
-              <a:buNone/>
+            <a:r>
+              <a:t>Mitigation strategies:</a:t>
+            </a:r>
+          </a:p>
+          <a:p>
+            <a:pPr>
+              <a:defRPr sz="1250" b="0">
+                <a:solidFill>
+                  <a:srgbClr val="444441"/>
+                </a:solidFill>
+              </a:defRPr>
             </a:pPr>
             <a:r>
-              <a:rPr lang="en-IN" sz="2400" b="1" i="0">
+              <a:t>• Weighted Cross-Entropy loss penalizes misclassification of advanced stages</a:t>
+            </a:r>
+          </a:p>
+          <a:p>
+            <a:pPr>
+              <a:defRPr sz="1250" b="0">
                 <a:solidFill>
-                  <a:schemeClr val="tx1"/>
+                  <a:srgbClr val="444441"/>
                 </a:solidFill>
-                <a:effectLst/>
-                <a:latin typeface="Bell MT" panose="02020503060305020303" pitchFamily="18" charset="0"/>
-              </a:rPr>
-              <a:t>Strategies:</a:t>
-            </a:r>
-          </a:p>
-          <a:p>
-            <a:pPr marL="342900" marR="0" lvl="0" indent="-342900" algn="l" rtl="0">
-              <a:lnSpc>
-                <a:spcPct val="100000"/>
-              </a:lnSpc>
-              <a:buFont typeface="Arial" panose="020B0604020202020204" pitchFamily="34" charset="0"/>
-              <a:buChar char="•"/>
+              </a:defRPr>
             </a:pPr>
             <a:r>
-              <a:rPr lang="en-IN" sz="1800" b="0" i="0">
+              <a:t>• LAB-space CLAHE preprocessing standardizes contrast across devices</a:t>
+            </a:r>
+          </a:p>
+          <a:p>
+            <a:pPr>
+              <a:defRPr sz="1250" b="0">
                 <a:solidFill>
-                  <a:schemeClr val="tx1"/>
+                  <a:srgbClr val="444441"/>
                 </a:solidFill>
-                <a:effectLst/>
-                <a:latin typeface="Calibri" pitchFamily="34" charset="0"/>
-              </a:rPr>
-              <a:t>Weighted loss for imbalance</a:t>
-            </a:r>
-          </a:p>
-          <a:p>
-            <a:pPr marL="342900" marR="0" lvl="0" indent="-342900" algn="l" rtl="0">
-              <a:lnSpc>
-                <a:spcPct val="100000"/>
-              </a:lnSpc>
-              <a:buFont typeface="Arial" panose="020B0604020202020204" pitchFamily="34" charset="0"/>
-              <a:buChar char="•"/>
+              </a:defRPr>
             </a:pPr>
             <a:r>
-              <a:rPr lang="en-IN" sz="1800" b="0" i="0" err="1">
+              <a:t>• Heatmap validation against clinical lesion patterns (microaneurysms/exudates)</a:t>
+            </a:r>
+          </a:p>
+          <a:p>
+            <a:pPr>
+              <a:defRPr sz="1250" b="0">
                 <a:solidFill>
-                  <a:schemeClr val="tx1"/>
+                  <a:srgbClr val="444441"/>
                 </a:solidFill>
-                <a:effectLst/>
-                <a:latin typeface="Calibri" pitchFamily="34" charset="0"/>
-              </a:rPr>
-              <a:t>CLAHE</a:t>
-            </a:r>
-            <a:r>
-              <a:rPr lang="en-IN" sz="1800" b="0" i="0">
-                <a:solidFill>
-                  <a:schemeClr val="tx1"/>
-                </a:solidFill>
-                <a:effectLst/>
-                <a:latin typeface="Calibri" pitchFamily="34" charset="0"/>
-              </a:rPr>
-              <a:t> preprocessing for image variation</a:t>
-            </a:r>
-          </a:p>
-          <a:p>
-            <a:pPr marL="342900" marR="0" lvl="0" indent="-342900" algn="l" rtl="0">
-              <a:lnSpc>
-                <a:spcPct val="100000"/>
-              </a:lnSpc>
-              <a:buFont typeface="Arial" panose="020B0604020202020204" pitchFamily="34" charset="0"/>
-              <a:buChar char="•"/>
+              </a:defRPr>
             </a:pPr>
             <a:r>
-              <a:rPr lang="en-IN" sz="1800" b="0" i="0">
-                <a:solidFill>
-                  <a:schemeClr val="tx1"/>
-                </a:solidFill>
-                <a:effectLst/>
-                <a:latin typeface="Calibri" pitchFamily="34" charset="0"/>
-              </a:rPr>
-              <a:t>Validate Grad-CAM against annotated lesion data</a:t>
-            </a:r>
-          </a:p>
-          <a:p>
-            <a:pPr marL="342900" marR="0" lvl="0" indent="-342900" algn="l" rtl="0">
-              <a:lnSpc>
-                <a:spcPct val="100000"/>
-              </a:lnSpc>
-              <a:buFont typeface="Arial" panose="020B0604020202020204" pitchFamily="34" charset="0"/>
-              <a:buChar char="•"/>
-            </a:pPr>
-            <a:r>
-              <a:rPr lang="en-IN" sz="1800" b="0" i="0">
-                <a:solidFill>
-                  <a:schemeClr val="tx1"/>
-                </a:solidFill>
-                <a:effectLst/>
-                <a:latin typeface="Calibri" pitchFamily="34" charset="0"/>
-              </a:rPr>
-              <a:t>Tune for high recall on severe cases</a:t>
-            </a:r>
-          </a:p>
-          <a:p>
-            <a:pPr marL="342900" marR="0" lvl="0" indent="-342900" algn="l" rtl="0">
-              <a:lnSpc>
-                <a:spcPct val="100000"/>
-              </a:lnSpc>
-              <a:buFont typeface="Arial" panose="020B0604020202020204" pitchFamily="34" charset="0"/>
-              <a:buChar char="•"/>
-            </a:pPr>
-            <a:r>
-              <a:rPr lang="en-IN" sz="1800" b="0" i="0">
-                <a:solidFill>
-                  <a:schemeClr val="tx1"/>
-                </a:solidFill>
-                <a:effectLst/>
-                <a:latin typeface="Calibri" pitchFamily="34" charset="0"/>
-              </a:rPr>
-              <a:t>Position as screening/referral aid, not final diagnosis</a:t>
-            </a:r>
-          </a:p>
-          <a:p>
-            <a:pPr>
-              <a:buNone/>
-            </a:pPr>
-            <a:br>
-              <a:rPr lang="en-IN"/>
-            </a:br>
-            <a:endParaRPr lang="en-IN"/>
+              <a:t>• Positioned strictly as clinical screening &amp; triaging aid, not autonomous diagnosis</a:t>
+            </a:r>
           </a:p>
         </p:txBody>
       </p:sp>
@@ -6951,7 +6757,7 @@
           <a:blip>
             <a:extLst>
               <a:ext uri="{96DAC541-7B7A-43D3-8B79-37D633B846F1}">
-                <asvg:svgBlip xmlns:asvg="http://schemas.microsoft.com/office/drawing/2016/SVG/main" r:embed="rId4"/>
+                <asvg:svgBlip xmlns:asvg="http://schemas.microsoft.com/office/drawing/2016/SVG/main" r:embed="rId3"/>
               </a:ext>
             </a:extLst>
           </a:blip>
@@ -6987,7 +6793,7 @@
           <a:blip>
             <a:extLst>
               <a:ext uri="{96DAC541-7B7A-43D3-8B79-37D633B846F1}">
-                <asvg:svgBlip xmlns:asvg="http://schemas.microsoft.com/office/drawing/2016/SVG/main" r:embed="rId5"/>
+                <asvg:svgBlip xmlns:asvg="http://schemas.microsoft.com/office/drawing/2016/SVG/main" r:embed="rId4"/>
               </a:ext>
             </a:extLst>
           </a:blip>
@@ -6999,6 +6805,36 @@
           <a:xfrm>
             <a:off x="6680389" y="4241228"/>
             <a:ext cx="4376089" cy="1969240"/>
+          </a:xfrm>
+          <a:prstGeom prst="rect">
+            <a:avLst/>
+          </a:prstGeom>
+        </p:spPr>
+      </p:pic>
+      <p:pic>
+        <p:nvPicPr>
+          <p:cNvPr id="3" name="Picture 2">
+            <a:extLst>
+              <a:ext uri="{FF2B5EF4-FFF2-40B4-BE49-F238E27FC236}">
+                <a16:creationId xmlns:a16="http://schemas.microsoft.com/office/drawing/2014/main" id="{D1F9ABAF-5DB4-C921-4F6D-7D4EF8F97070}"/>
+              </a:ext>
+            </a:extLst>
+          </p:cNvPr>
+          <p:cNvPicPr>
+            <a:picLocks noChangeAspect="1"/>
+          </p:cNvPicPr>
+          <p:nvPr/>
+        </p:nvPicPr>
+        <p:blipFill>
+          <a:blip r:embed="rId5"/>
+          <a:stretch>
+            <a:fillRect/>
+          </a:stretch>
+        </p:blipFill>
+        <p:spPr>
+          <a:xfrm>
+            <a:off x="10534650" y="104656"/>
+            <a:ext cx="1657350" cy="919163"/>
           </a:xfrm>
           <a:prstGeom prst="rect">
             <a:avLst/>
@@ -7115,53 +6951,6 @@
           </a:p>
         </p:txBody>
       </p:sp>
-      <p:pic>
-        <p:nvPicPr>
-          <p:cNvPr id="4" name="Picture 2" descr="https://www.sih.gov.in/img1/SIH-Logo.png">
-            <a:extLst>
-              <a:ext uri="{FF2B5EF4-FFF2-40B4-BE49-F238E27FC236}">
-                <a16:creationId xmlns:a16="http://schemas.microsoft.com/office/drawing/2014/main" id="{4E91CEBF-E787-8E55-D069-19FE95CE2660}"/>
-              </a:ext>
-            </a:extLst>
-          </p:cNvPr>
-          <p:cNvPicPr>
-            <a:picLocks noChangeAspect="1" noChangeArrowheads="1"/>
-          </p:cNvPicPr>
-          <p:nvPr/>
-        </p:nvPicPr>
-        <p:blipFill>
-          <a:blip r:embed="rId3">
-            <a:extLst>
-              <a:ext uri="{28A0092B-C50C-407E-A947-70E740481C1C}">
-                <a14:useLocalDpi xmlns:a14="http://schemas.microsoft.com/office/drawing/2010/main" val="0"/>
-              </a:ext>
-            </a:extLst>
-          </a:blip>
-          <a:srcRect/>
-          <a:stretch>
-            <a:fillRect/>
-          </a:stretch>
-        </p:blipFill>
-        <p:spPr bwMode="auto">
-          <a:xfrm>
-            <a:off x="10595331" y="84459"/>
-            <a:ext cx="1399445" cy="711321"/>
-          </a:xfrm>
-          <a:prstGeom prst="rect">
-            <a:avLst/>
-          </a:prstGeom>
-          <a:noFill/>
-          <a:extLst>
-            <a:ext uri="{909E8E84-426E-40DD-AFC4-6F175D3DCCD1}">
-              <a14:hiddenFill xmlns:a14="http://schemas.microsoft.com/office/drawing/2010/main">
-                <a:solidFill>
-                  <a:srgbClr val="FFFFFF"/>
-                </a:solidFill>
-              </a14:hiddenFill>
-            </a:ext>
-          </a:extLst>
-        </p:spPr>
-      </p:pic>
       <p:sp>
         <p:nvSpPr>
           <p:cNvPr id="7" name="Oval 6" descr="Your startup LOGO">
@@ -7256,136 +7045,6 @@
       </p:sp>
       <p:sp>
         <p:nvSpPr>
-          <p:cNvPr id="16" name="TextBox 15">
-            <a:extLst>
-              <a:ext uri="{FF2B5EF4-FFF2-40B4-BE49-F238E27FC236}">
-                <a16:creationId xmlns:a16="http://schemas.microsoft.com/office/drawing/2014/main" id="{837429C3-E6C2-4409-2880-1C2FAB339B6E}"/>
-              </a:ext>
-            </a:extLst>
-          </p:cNvPr>
-          <p:cNvSpPr txBox="1"/>
-          <p:nvPr/>
-        </p:nvSpPr>
-        <p:spPr>
-          <a:xfrm>
-            <a:off x="2164690" y="2036560"/>
-            <a:ext cx="1911199" cy="461665"/>
-          </a:xfrm>
-          <a:prstGeom prst="rect">
-            <a:avLst/>
-          </a:prstGeom>
-          <a:noFill/>
-        </p:spPr>
-        <p:txBody>
-          <a:bodyPr wrap="square">
-            <a:spAutoFit/>
-          </a:bodyPr>
-          <a:lstStyle/>
-          <a:p>
-            <a:r>
-              <a:rPr lang="en-US" sz="2400">
-                <a:solidFill>
-                  <a:schemeClr val="bg1"/>
-                </a:solidFill>
-                <a:latin typeface="Bell MT" panose="02020503060305020303" pitchFamily="18" charset="0"/>
-              </a:rPr>
-              <a:t>Technologies</a:t>
-            </a:r>
-            <a:endParaRPr lang="en-IN" sz="2400">
-              <a:solidFill>
-                <a:schemeClr val="bg1"/>
-              </a:solidFill>
-              <a:latin typeface="Bell MT" panose="02020503060305020303" pitchFamily="18" charset="0"/>
-            </a:endParaRPr>
-          </a:p>
-        </p:txBody>
-      </p:sp>
-      <p:sp>
-        <p:nvSpPr>
-          <p:cNvPr id="19" name="TextBox 18">
-            <a:extLst>
-              <a:ext uri="{FF2B5EF4-FFF2-40B4-BE49-F238E27FC236}">
-                <a16:creationId xmlns:a16="http://schemas.microsoft.com/office/drawing/2014/main" id="{E7557ECA-62F1-A5A2-4383-28CFB09AB299}"/>
-              </a:ext>
-            </a:extLst>
-          </p:cNvPr>
-          <p:cNvSpPr txBox="1"/>
-          <p:nvPr/>
-        </p:nvSpPr>
-        <p:spPr>
-          <a:xfrm>
-            <a:off x="8195880" y="1978455"/>
-            <a:ext cx="1911199" cy="461665"/>
-          </a:xfrm>
-          <a:prstGeom prst="rect">
-            <a:avLst/>
-          </a:prstGeom>
-          <a:noFill/>
-        </p:spPr>
-        <p:txBody>
-          <a:bodyPr wrap="square">
-            <a:spAutoFit/>
-          </a:bodyPr>
-          <a:lstStyle/>
-          <a:p>
-            <a:r>
-              <a:rPr lang="en-US" sz="2400">
-                <a:solidFill>
-                  <a:schemeClr val="bg1"/>
-                </a:solidFill>
-                <a:latin typeface="Bell MT" panose="02020503060305020303" pitchFamily="18" charset="0"/>
-              </a:rPr>
-              <a:t>Methodology</a:t>
-            </a:r>
-            <a:endParaRPr lang="en-IN" sz="2400">
-              <a:solidFill>
-                <a:schemeClr val="bg1"/>
-              </a:solidFill>
-              <a:latin typeface="Bell MT" panose="02020503060305020303" pitchFamily="18" charset="0"/>
-            </a:endParaRPr>
-          </a:p>
-        </p:txBody>
-      </p:sp>
-      <p:sp>
-        <p:nvSpPr>
-          <p:cNvPr id="10" name="TextBox 9">
-            <a:extLst>
-              <a:ext uri="{FF2B5EF4-FFF2-40B4-BE49-F238E27FC236}">
-                <a16:creationId xmlns:a16="http://schemas.microsoft.com/office/drawing/2014/main" id="{EB3224DB-3C0C-D76F-3ACB-A12BFC89A688}"/>
-              </a:ext>
-            </a:extLst>
-          </p:cNvPr>
-          <p:cNvSpPr txBox="1"/>
-          <p:nvPr/>
-        </p:nvSpPr>
-        <p:spPr>
-          <a:xfrm>
-            <a:off x="243190" y="1611603"/>
-            <a:ext cx="6614809" cy="646331"/>
-          </a:xfrm>
-          <a:prstGeom prst="rect">
-            <a:avLst/>
-          </a:prstGeom>
-          <a:noFill/>
-        </p:spPr>
-        <p:txBody>
-          <a:bodyPr wrap="square">
-            <a:spAutoFit/>
-          </a:bodyPr>
-          <a:lstStyle/>
-          <a:p>
-            <a:pPr>
-              <a:buNone/>
-            </a:pPr>
-            <a:br>
-              <a:rPr lang="en-IN"/>
-            </a:br>
-            <a:endParaRPr lang="en-IN"/>
-          </a:p>
-        </p:txBody>
-      </p:sp>
-      <p:sp>
-        <p:nvSpPr>
           <p:cNvPr id="3" name="TextBox 2">
             <a:extLst>
               <a:ext uri="{FF2B5EF4-FFF2-40B4-BE49-F238E27FC236}">
@@ -7414,11 +7073,13 @@
           <a:p>
             <a:pPr rtl="0">
               <a:buNone/>
+              <a:defRPr sz="1700" b="1">
+                <a:solidFill>
+                  <a:srgbClr val="0B0B0B"/>
+                </a:solidFill>
+              </a:defRPr>
             </a:pPr>
             <a:r>
-              <a:rPr lang="en-IN" sz="2400" b="1">
-                <a:latin typeface="Bell MT" panose="02020503060305020303" pitchFamily="18" charset="0"/>
-              </a:rPr>
               <a:t>Potential impact on the target audience:</a:t>
             </a:r>
             <a:endParaRPr lang="en-IN" sz="2400">
@@ -7426,144 +7087,140 @@
             </a:endParaRPr>
           </a:p>
           <a:p>
-            <a:pPr marL="342900" lvl="0" indent="-342900" rtl="0">
-              <a:buFont typeface="Arial" panose="020B0604020202020204" pitchFamily="34" charset="0"/>
-              <a:buChar char="•"/>
+            <a:pPr>
+              <a:defRPr sz="1250" b="0">
+                <a:solidFill>
+                  <a:srgbClr val="444441"/>
+                </a:solidFill>
+              </a:defRPr>
             </a:pPr>
             <a:r>
-              <a:rPr lang="en-IN"/>
-              <a:t>Rural/PHC patients get early DR screening without traveling to a specialist</a:t>
-            </a:r>
-          </a:p>
-          <a:p>
-            <a:pPr marL="342900" lvl="0" indent="-342900" rtl="0">
-              <a:buFont typeface="Arial" panose="020B0604020202020204" pitchFamily="34" charset="0"/>
-              <a:buChar char="•"/>
+              <a:t>• Rural &amp; PHC patients get early DR screening without traveling to distant specialists</a:t>
+            </a:r>
+          </a:p>
+          <a:p>
+            <a:pPr>
+              <a:defRPr sz="1250" b="0">
+                <a:solidFill>
+                  <a:srgbClr val="444441"/>
+                </a:solidFill>
+              </a:defRPr>
             </a:pPr>
             <a:r>
-              <a:rPr lang="en-IN"/>
-              <a:t>Health workers get a trustworthy, explainable second opinion, not a black box</a:t>
-            </a:r>
-          </a:p>
-          <a:p>
-            <a:pPr marL="342900" lvl="0" indent="-342900" rtl="0">
-              <a:buFont typeface="Arial" panose="020B0604020202020204" pitchFamily="34" charset="0"/>
-              <a:buChar char="•"/>
+              <a:t>• Primary health workers get an explainable, trustworthy decision-support aid</a:t>
+            </a:r>
+          </a:p>
+          <a:p>
+            <a:pPr>
+              <a:defRPr sz="1250" b="0">
+                <a:solidFill>
+                  <a:srgbClr val="444441"/>
+                </a:solidFill>
+              </a:defRPr>
             </a:pPr>
             <a:r>
-              <a:rPr lang="en-IN"/>
-              <a:t>Enables earlier referral before vision loss becomes irreversible</a:t>
-            </a:r>
-          </a:p>
-          <a:p>
-            <a:pPr marL="342900" lvl="0" indent="-342900" rtl="0">
-              <a:buFont typeface="Arial" panose="020B0604020202020204" pitchFamily="34" charset="0"/>
-              <a:buChar char="•"/>
+              <a:t>• Enables timely referrals before irreversible vision loss occurs</a:t>
+            </a:r>
+          </a:p>
+          <a:p>
+            <a:pPr>
+              <a:defRPr sz="1250" b="0">
+                <a:solidFill>
+                  <a:srgbClr val="444441"/>
+                </a:solidFill>
+              </a:defRPr>
             </a:pPr>
             <a:r>
-              <a:rPr lang="en-IN"/>
-              <a:t>Reduces the burden on India's limited pool of ophthalmologists for first-level screening</a:t>
-            </a:r>
-          </a:p>
-          <a:p>
-            <a:pPr marL="342900" lvl="0" indent="-342900" rtl="0">
-              <a:buFont typeface="Arial" panose="020B0604020202020204" pitchFamily="34" charset="0"/>
-              <a:buChar char="•"/>
+              <a:t>• Alleviates burden on India's scarce pool of ophthalmologists (~1 per 100,000 in rural areas)</a:t>
+            </a:r>
+          </a:p>
+          <a:p>
+            <a:pPr>
+              <a:defRPr sz="1250" b="0">
+                <a:solidFill>
+                  <a:srgbClr val="444441"/>
+                </a:solidFill>
+              </a:defRPr>
             </a:pPr>
             <a:r>
-              <a:rPr lang="en-IN"/>
-              <a:t>Builds patient trust and follow-up compliance since they can see the visual reasoning, not just a verdict</a:t>
-            </a:r>
-          </a:p>
-          <a:p>
-            <a:pPr marL="342900" lvl="0" indent="-342900" rtl="0">
-              <a:buFont typeface="Arial" panose="020B0604020202020204" pitchFamily="34" charset="0"/>
-              <a:buChar char="•"/>
+              <a:t>• Visual Grad-CAM evidence builds patient confidence and follow-up adherence</a:t>
+            </a:r>
+          </a:p>
+          <a:p>
+            <a:pPr>
+              <a:defRPr sz="500" b="0"/>
             </a:pPr>
-            <a:endParaRPr lang="en-IN"/>
-          </a:p>
-          <a:p>
-            <a:pPr rtl="0">
-              <a:buNone/>
+          </a:p>
+          <a:p>
+            <a:pPr>
+              <a:defRPr sz="1700" b="1">
+                <a:solidFill>
+                  <a:srgbClr val="0B0B0B"/>
+                </a:solidFill>
+              </a:defRPr>
             </a:pPr>
             <a:r>
-              <a:rPr lang="en-IN" sz="2400" b="1">
-                <a:latin typeface="Bell MT" panose="02020503060305020303" pitchFamily="18" charset="0"/>
-              </a:rPr>
               <a:t>Benefits of the solution:</a:t>
             </a:r>
-            <a:endParaRPr lang="en-IN" sz="2400">
-              <a:latin typeface="Bell MT" panose="02020503060305020303" pitchFamily="18" charset="0"/>
-            </a:endParaRPr>
-          </a:p>
-          <a:p>
-            <a:pPr marL="342900" lvl="0" indent="-342900" rtl="0">
-              <a:buFont typeface="Arial" panose="020B0604020202020204" pitchFamily="34" charset="0"/>
-              <a:buChar char="•"/>
+          </a:p>
+          <a:p>
+            <a:pPr>
+              <a:defRPr sz="1250" b="0">
+                <a:solidFill>
+                  <a:srgbClr val="444441"/>
+                </a:solidFill>
+              </a:defRPr>
             </a:pPr>
             <a:r>
-              <a:rPr lang="en-IN" b="1"/>
-              <a:t>Social:</a:t>
-            </a:r>
-            <a:r>
-              <a:rPr lang="en-IN"/>
-              <a:t> wider access to eye care, fewer preventable blindness cases</a:t>
-            </a:r>
-          </a:p>
-          <a:p>
-            <a:pPr marL="342900" lvl="0" indent="-342900" rtl="0">
-              <a:buFont typeface="Arial" panose="020B0604020202020204" pitchFamily="34" charset="0"/>
-              <a:buChar char="•"/>
+              <a:t>• Social: Democratizes access to specialized eye care, preventing avoidable blindness</a:t>
+            </a:r>
+          </a:p>
+          <a:p>
+            <a:pPr>
+              <a:defRPr sz="1250" b="0">
+                <a:solidFill>
+                  <a:srgbClr val="444441"/>
+                </a:solidFill>
+              </a:defRPr>
             </a:pPr>
             <a:r>
-              <a:rPr lang="en-IN" b="1"/>
-              <a:t>Economic:</a:t>
-            </a:r>
-            <a:r>
-              <a:rPr lang="en-IN"/>
-              <a:t> less specialist dependency, avoids costlier late-stage treatment</a:t>
-            </a:r>
-          </a:p>
-          <a:p>
-            <a:pPr marL="342900" lvl="0" indent="-342900" rtl="0">
-              <a:buFont typeface="Arial" panose="020B0604020202020204" pitchFamily="34" charset="0"/>
-              <a:buChar char="•"/>
+              <a:t>• Economic: Minimizes costly surgical interventions through early asymptomatic detection</a:t>
+            </a:r>
+          </a:p>
+          <a:p>
+            <a:pPr>
+              <a:defRPr sz="1250" b="0">
+                <a:solidFill>
+                  <a:srgbClr val="444441"/>
+                </a:solidFill>
+              </a:defRPr>
             </a:pPr>
             <a:r>
-              <a:rPr lang="en-IN" b="1"/>
-              <a:t>Operational:</a:t>
-            </a:r>
-            <a:r>
-              <a:rPr lang="en-IN"/>
-              <a:t> offline-first, no cloud/connectivity cost</a:t>
-            </a:r>
-          </a:p>
-          <a:p>
-            <a:pPr marL="342900" lvl="0" indent="-342900" rtl="0">
-              <a:buFont typeface="Arial" panose="020B0604020202020204" pitchFamily="34" charset="0"/>
-              <a:buChar char="•"/>
+              <a:t>• Operational: 100% offline-first architecture — zero cloud subscription or bandwidth costs</a:t>
+            </a:r>
+          </a:p>
+          <a:p>
+            <a:pPr>
+              <a:defRPr sz="1250" b="0">
+                <a:solidFill>
+                  <a:srgbClr val="444441"/>
+                </a:solidFill>
+              </a:defRPr>
             </a:pPr>
             <a:r>
-              <a:rPr lang="en-IN" b="1"/>
-              <a:t>Scalability:</a:t>
-            </a:r>
-            <a:r>
-              <a:rPr lang="en-IN"/>
-              <a:t> batch mode screens full health camps in one sitting</a:t>
-            </a:r>
-          </a:p>
-          <a:p>
-            <a:pPr marL="342900" lvl="0" indent="-342900" rtl="0">
-              <a:buFont typeface="Arial" panose="020B0604020202020204" pitchFamily="34" charset="0"/>
-              <a:buChar char="•"/>
+              <a:t>• Scalability: Fast ~0.4s inference enables high patient throughput at rural screening camps</a:t>
+            </a:r>
+          </a:p>
+          <a:p>
+            <a:pPr>
+              <a:defRPr sz="1250" b="0">
+                <a:solidFill>
+                  <a:srgbClr val="444441"/>
+                </a:solidFill>
+              </a:defRPr>
             </a:pPr>
             <a:r>
-              <a:rPr lang="en-IN" b="1"/>
-              <a:t>Sustainability:</a:t>
-            </a:r>
-            <a:r>
-              <a:rPr lang="en-IN"/>
-              <a:t> low-hardware requirement keeps long-term running cost near zero for clinics</a:t>
+              <a:t>• Sustainability: Minimal CPU hardware requirement ensures long-term rural viability</a:t>
             </a:r>
           </a:p>
         </p:txBody>
@@ -7583,7 +7240,7 @@
           <p:nvPr/>
         </p:nvPicPr>
         <p:blipFill>
-          <a:blip r:embed="rId4"/>
+          <a:blip r:embed="rId3"/>
           <a:stretch>
             <a:fillRect/>
           </a:stretch>
@@ -7616,7 +7273,7 @@
           <a:blip>
             <a:extLst>
               <a:ext uri="{96DAC541-7B7A-43D3-8B79-37D633B846F1}">
-                <asvg:svgBlip xmlns:asvg="http://schemas.microsoft.com/office/drawing/2016/SVG/main" r:embed="rId5"/>
+                <asvg:svgBlip xmlns:asvg="http://schemas.microsoft.com/office/drawing/2016/SVG/main" r:embed="rId4"/>
               </a:ext>
             </a:extLst>
           </a:blip>
@@ -7628,6 +7285,36 @@
           <a:xfrm>
             <a:off x="6340003" y="2786340"/>
             <a:ext cx="6477000" cy="4000500"/>
+          </a:xfrm>
+          <a:prstGeom prst="rect">
+            <a:avLst/>
+          </a:prstGeom>
+        </p:spPr>
+      </p:pic>
+      <p:pic>
+        <p:nvPicPr>
+          <p:cNvPr id="5" name="Picture 4">
+            <a:extLst>
+              <a:ext uri="{FF2B5EF4-FFF2-40B4-BE49-F238E27FC236}">
+                <a16:creationId xmlns:a16="http://schemas.microsoft.com/office/drawing/2014/main" id="{62E03E21-C792-1363-2E79-10233DBDB4A0}"/>
+              </a:ext>
+            </a:extLst>
+          </p:cNvPr>
+          <p:cNvPicPr>
+            <a:picLocks noChangeAspect="1"/>
+          </p:cNvPicPr>
+          <p:nvPr/>
+        </p:nvPicPr>
+        <p:blipFill>
+          <a:blip r:embed="rId5"/>
+          <a:stretch>
+            <a:fillRect/>
+          </a:stretch>
+        </p:blipFill>
+        <p:spPr>
+          <a:xfrm>
+            <a:off x="10534650" y="71160"/>
+            <a:ext cx="1657350" cy="919163"/>
           </a:xfrm>
           <a:prstGeom prst="rect">
             <a:avLst/>
@@ -7744,53 +7431,6 @@
           </a:p>
         </p:txBody>
       </p:sp>
-      <p:pic>
-        <p:nvPicPr>
-          <p:cNvPr id="4" name="Picture 2" descr="https://www.sih.gov.in/img1/SIH-Logo.png">
-            <a:extLst>
-              <a:ext uri="{FF2B5EF4-FFF2-40B4-BE49-F238E27FC236}">
-                <a16:creationId xmlns:a16="http://schemas.microsoft.com/office/drawing/2014/main" id="{8DCB0308-F01A-B8A2-CFDD-E13AD7060B5A}"/>
-              </a:ext>
-            </a:extLst>
-          </p:cNvPr>
-          <p:cNvPicPr>
-            <a:picLocks noChangeAspect="1" noChangeArrowheads="1"/>
-          </p:cNvPicPr>
-          <p:nvPr/>
-        </p:nvPicPr>
-        <p:blipFill>
-          <a:blip r:embed="rId3">
-            <a:extLst>
-              <a:ext uri="{28A0092B-C50C-407E-A947-70E740481C1C}">
-                <a14:useLocalDpi xmlns:a14="http://schemas.microsoft.com/office/drawing/2010/main" val="0"/>
-              </a:ext>
-            </a:extLst>
-          </a:blip>
-          <a:srcRect/>
-          <a:stretch>
-            <a:fillRect/>
-          </a:stretch>
-        </p:blipFill>
-        <p:spPr bwMode="auto">
-          <a:xfrm>
-            <a:off x="10595331" y="84459"/>
-            <a:ext cx="1399445" cy="711321"/>
-          </a:xfrm>
-          <a:prstGeom prst="rect">
-            <a:avLst/>
-          </a:prstGeom>
-          <a:noFill/>
-          <a:extLst>
-            <a:ext uri="{909E8E84-426E-40DD-AFC4-6F175D3DCCD1}">
-              <a14:hiddenFill xmlns:a14="http://schemas.microsoft.com/office/drawing/2010/main">
-                <a:solidFill>
-                  <a:srgbClr val="FFFFFF"/>
-                </a:solidFill>
-              </a14:hiddenFill>
-            </a:ext>
-          </a:extLst>
-        </p:spPr>
-      </p:pic>
       <p:sp>
         <p:nvSpPr>
           <p:cNvPr id="7" name="Oval 6" descr="Your startup LOGO">
@@ -7874,142 +7514,8 @@
           <a:lstStyle/>
           <a:p>
             <a:r>
-              <a:rPr lang="en-IN" sz="2400" b="1">
-                <a:latin typeface="Times New Roman" panose="02020603050405020304" pitchFamily="18" charset="0"/>
-                <a:cs typeface="Times New Roman" panose="02020603050405020304" pitchFamily="18" charset="0"/>
-              </a:rPr>
-              <a:t>IMPACT AND BENEFITS</a:t>
-            </a:r>
-          </a:p>
-        </p:txBody>
-      </p:sp>
-      <p:sp>
-        <p:nvSpPr>
-          <p:cNvPr id="16" name="TextBox 15">
-            <a:extLst>
-              <a:ext uri="{FF2B5EF4-FFF2-40B4-BE49-F238E27FC236}">
-                <a16:creationId xmlns:a16="http://schemas.microsoft.com/office/drawing/2014/main" id="{57F8371B-9384-1E99-21DF-58020B2EDE5B}"/>
-              </a:ext>
-            </a:extLst>
-          </p:cNvPr>
-          <p:cNvSpPr txBox="1"/>
-          <p:nvPr/>
-        </p:nvSpPr>
-        <p:spPr>
-          <a:xfrm>
-            <a:off x="2164690" y="2036560"/>
-            <a:ext cx="1911199" cy="461665"/>
-          </a:xfrm>
-          <a:prstGeom prst="rect">
-            <a:avLst/>
-          </a:prstGeom>
-          <a:noFill/>
-        </p:spPr>
-        <p:txBody>
-          <a:bodyPr wrap="square">
-            <a:spAutoFit/>
-          </a:bodyPr>
-          <a:lstStyle/>
-          <a:p>
-            <a:r>
-              <a:rPr lang="en-US" sz="2400">
-                <a:solidFill>
-                  <a:schemeClr val="bg1"/>
-                </a:solidFill>
-                <a:latin typeface="Bell MT" panose="02020503060305020303" pitchFamily="18" charset="0"/>
-              </a:rPr>
-              <a:t>Technologies</a:t>
-            </a:r>
-            <a:endParaRPr lang="en-IN" sz="2400">
-              <a:solidFill>
-                <a:schemeClr val="bg1"/>
-              </a:solidFill>
-              <a:latin typeface="Bell MT" panose="02020503060305020303" pitchFamily="18" charset="0"/>
-            </a:endParaRPr>
-          </a:p>
-        </p:txBody>
-      </p:sp>
-      <p:sp>
-        <p:nvSpPr>
-          <p:cNvPr id="19" name="TextBox 18">
-            <a:extLst>
-              <a:ext uri="{FF2B5EF4-FFF2-40B4-BE49-F238E27FC236}">
-                <a16:creationId xmlns:a16="http://schemas.microsoft.com/office/drawing/2014/main" id="{7CEA1E28-3B88-6F41-A454-223D2CFC32DA}"/>
-              </a:ext>
-            </a:extLst>
-          </p:cNvPr>
-          <p:cNvSpPr txBox="1"/>
-          <p:nvPr/>
-        </p:nvSpPr>
-        <p:spPr>
-          <a:xfrm>
-            <a:off x="8195880" y="1978455"/>
-            <a:ext cx="1911199" cy="461665"/>
-          </a:xfrm>
-          <a:prstGeom prst="rect">
-            <a:avLst/>
-          </a:prstGeom>
-          <a:noFill/>
-        </p:spPr>
-        <p:txBody>
-          <a:bodyPr wrap="square">
-            <a:spAutoFit/>
-          </a:bodyPr>
-          <a:lstStyle/>
-          <a:p>
-            <a:r>
-              <a:rPr lang="en-US" sz="2400">
-                <a:solidFill>
-                  <a:schemeClr val="bg1"/>
-                </a:solidFill>
-                <a:latin typeface="Bell MT" panose="02020503060305020303" pitchFamily="18" charset="0"/>
-              </a:rPr>
-              <a:t>Methodology</a:t>
-            </a:r>
-            <a:endParaRPr lang="en-IN" sz="2400">
-              <a:solidFill>
-                <a:schemeClr val="bg1"/>
-              </a:solidFill>
-              <a:latin typeface="Bell MT" panose="02020503060305020303" pitchFamily="18" charset="0"/>
-            </a:endParaRPr>
-          </a:p>
-        </p:txBody>
-      </p:sp>
-      <p:sp>
-        <p:nvSpPr>
-          <p:cNvPr id="10" name="TextBox 9">
-            <a:extLst>
-              <a:ext uri="{FF2B5EF4-FFF2-40B4-BE49-F238E27FC236}">
-                <a16:creationId xmlns:a16="http://schemas.microsoft.com/office/drawing/2014/main" id="{0AA1E99E-253B-5B6D-DDDF-FA78392D3DB6}"/>
-              </a:ext>
-            </a:extLst>
-          </p:cNvPr>
-          <p:cNvSpPr txBox="1"/>
-          <p:nvPr/>
-        </p:nvSpPr>
-        <p:spPr>
-          <a:xfrm>
-            <a:off x="243190" y="1611603"/>
-            <a:ext cx="6614809" cy="646331"/>
-          </a:xfrm>
-          <a:prstGeom prst="rect">
-            <a:avLst/>
-          </a:prstGeom>
-          <a:noFill/>
-        </p:spPr>
-        <p:txBody>
-          <a:bodyPr wrap="square">
-            <a:spAutoFit/>
-          </a:bodyPr>
-          <a:lstStyle/>
-          <a:p>
-            <a:pPr>
-              <a:buNone/>
-            </a:pPr>
-            <a:br>
-              <a:rPr lang="en-IN"/>
-            </a:br>
-            <a:endParaRPr lang="en-IN"/>
+              <a:t>RESEARCH AND REFERENCES</a:t>
+            </a:r>
           </a:p>
         </p:txBody>
       </p:sp>
@@ -8072,7 +7578,7 @@
           <a:blip>
             <a:extLst>
               <a:ext uri="{96DAC541-7B7A-43D3-8B79-37D633B846F1}">
-                <asvg:svgBlip xmlns:asvg="http://schemas.microsoft.com/office/drawing/2016/SVG/main" r:embed="rId4"/>
+                <asvg:svgBlip xmlns:asvg="http://schemas.microsoft.com/office/drawing/2016/SVG/main" r:embed="rId3"/>
               </a:ext>
             </a:extLst>
           </a:blip>
@@ -8084,6 +7590,36 @@
           <a:xfrm>
             <a:off x="72289" y="1589818"/>
             <a:ext cx="8982358" cy="3962805"/>
+          </a:xfrm>
+          <a:prstGeom prst="rect">
+            <a:avLst/>
+          </a:prstGeom>
+        </p:spPr>
+      </p:pic>
+      <p:pic>
+        <p:nvPicPr>
+          <p:cNvPr id="3" name="Picture 2">
+            <a:extLst>
+              <a:ext uri="{FF2B5EF4-FFF2-40B4-BE49-F238E27FC236}">
+                <a16:creationId xmlns:a16="http://schemas.microsoft.com/office/drawing/2014/main" id="{EA5A9DB6-6FEE-0539-AB6D-0E5F53D4FD06}"/>
+              </a:ext>
+            </a:extLst>
+          </p:cNvPr>
+          <p:cNvPicPr>
+            <a:picLocks noChangeAspect="1"/>
+          </p:cNvPicPr>
+          <p:nvPr/>
+        </p:nvPicPr>
+        <p:blipFill>
+          <a:blip r:embed="rId4"/>
+          <a:stretch>
+            <a:fillRect/>
+          </a:stretch>
+        </p:blipFill>
+        <p:spPr>
+          <a:xfrm>
+            <a:off x="10534650" y="154222"/>
+            <a:ext cx="1657350" cy="919163"/>
           </a:xfrm>
           <a:prstGeom prst="rect">
             <a:avLst/>

</xml_diff>